<commit_message>
Strengthen report with in-class references and external academic sources
Add Gallery Walk, Opinion Spectrum, Turing Game, and Data vs. Experience
references. Add external sources: Lyria 3/SynthID, authorship bias study,
DAACI framework, Suno/Udio lawsuits, Thaler v. Perlmutter, Walter Benjamin,
Sherry Turkle. Embed chat screenshots into presentation slides 3 and 4.

Co-Authored-By: Claude Opus 4.6 (1M context) <noreply@anthropic.com>
</commit_message>
<xml_diff>
--- a/Assignment_1_AI_Music_Generation/PHKI_Assignment1_Presentation.pptx
+++ b/Assignment_1_AI_Music_Generation/PHKI_Assignment1_Presentation.pptx
@@ -3874,16 +3874,40 @@
           </a:p>
         </p:txBody>
       </p:sp>
-      <p:sp>
-        <p:nvSpPr>
-          <p:cNvPr id="7" name="TextBox 6"/>
+      <p:pic>
+        <p:nvPicPr>
+          <p:cNvPr id="7" name="Picture 6" descr="Chat_1_01.png"/>
+          <p:cNvPicPr>
+            <a:picLocks noChangeAspect="1"/>
+          </p:cNvPicPr>
+          <p:nvPr/>
+        </p:nvPicPr>
+        <p:blipFill>
+          <a:blip r:embed="rId2"/>
+          <a:stretch>
+            <a:fillRect/>
+          </a:stretch>
+        </p:blipFill>
+        <p:spPr>
+          <a:xfrm>
+            <a:off x="6858000" y="1737360"/>
+            <a:ext cx="3025833" cy="4754880"/>
+          </a:xfrm>
+          <a:prstGeom prst="rect">
+            <a:avLst/>
+          </a:prstGeom>
+        </p:spPr>
+      </p:pic>
+      <p:sp>
+        <p:nvSpPr>
+          <p:cNvPr id="8" name="TextBox 7"/>
           <p:cNvSpPr txBox="1"/>
           <p:nvPr/>
         </p:nvSpPr>
         <p:spPr>
           <a:xfrm>
-            <a:off x="6400800" y="1828800"/>
-            <a:ext cx="5029200" cy="457200"/>
+            <a:off x="731520" y="4389120"/>
+            <a:ext cx="5669280" cy="457200"/>
           </a:xfrm>
           <a:prstGeom prst="rect">
             <a:avLst/>
@@ -3898,34 +3922,34 @@
           <a:p>
             <a:pPr algn="l">
               <a:lnSpc>
-                <a:spcPts val="1690"/>
+                <a:spcPts val="2860"/>
               </a:lnSpc>
               <a:spcAft>
                 <a:spcPts val="400"/>
               </a:spcAft>
             </a:pPr>
             <a:r>
-              <a:rPr sz="1300" b="1" i="0">
-                <a:solidFill>
-                  <a:srgbClr val="4A90D9"/>
+              <a:rPr sz="2200" b="1" i="0">
+                <a:solidFill>
+                  <a:srgbClr val="FFFFFF"/>
                 </a:solidFill>
                 <a:latin typeface="Calibri"/>
               </a:rPr>
-              <a:t>GEMINI’S RESPONSE</a:t>
-            </a:r>
-          </a:p>
-        </p:txBody>
-      </p:sp>
-      <p:sp>
-        <p:nvSpPr>
-          <p:cNvPr id="8" name="TextBox 7"/>
+              <a:t>“Synthetic Pine &amp; Heavy Air”</a:t>
+            </a:r>
+          </a:p>
+        </p:txBody>
+      </p:sp>
+      <p:sp>
+        <p:nvSpPr>
+          <p:cNvPr id="9" name="TextBox 8"/>
           <p:cNvSpPr txBox="1"/>
           <p:nvPr/>
         </p:nvSpPr>
         <p:spPr>
           <a:xfrm>
-            <a:off x="6400800" y="2286000"/>
-            <a:ext cx="5029200" cy="914400"/>
+            <a:off x="731520" y="5029200"/>
+            <a:ext cx="5669280" cy="1371600"/>
           </a:xfrm>
           <a:prstGeom prst="rect">
             <a:avLst/>
@@ -3938,186 +3962,60 @@
           </a:bodyPr>
           <a:lstStyle/>
           <a:p>
-            <a:pPr algn="l">
-              <a:lnSpc>
-                <a:spcPts val="2240"/>
-              </a:lnSpc>
-              <a:spcAft>
-                <a:spcPts val="400"/>
-              </a:spcAft>
-            </a:pPr>
-            <a:r>
-              <a:rPr sz="1600" b="1" i="0">
-                <a:solidFill>
-                  <a:srgbClr val="D48B2C"/>
-                </a:solidFill>
-                <a:latin typeface="Calibri"/>
-              </a:rPr>
-              <a:t>“I can’t recreate the exact melody or use that specific song’s IP.”</a:t>
-            </a:r>
-          </a:p>
-        </p:txBody>
-      </p:sp>
-      <p:sp>
-        <p:nvSpPr>
-          <p:cNvPr id="9" name="TextBox 8"/>
-          <p:cNvSpPr txBox="1"/>
-          <p:nvPr/>
-        </p:nvSpPr>
-        <p:spPr>
-          <a:xfrm>
-            <a:off x="6400800" y="3200400"/>
-            <a:ext cx="5029200" cy="1097280"/>
-          </a:xfrm>
-          <a:prstGeom prst="rect">
-            <a:avLst/>
-          </a:prstGeom>
-          <a:noFill/>
-        </p:spPr>
-        <p:txBody>
-          <a:bodyPr wrap="square">
-            <a:spAutoFit/>
-          </a:bodyPr>
-          <a:lstStyle/>
-          <a:p>
-            <a:pPr algn="l">
-              <a:lnSpc>
-                <a:spcPts val="2100"/>
-              </a:lnSpc>
-              <a:spcAft>
-                <a:spcPts val="400"/>
-              </a:spcAft>
-            </a:pPr>
-            <a:r>
-              <a:rPr sz="1500" b="0" i="0">
-                <a:solidFill>
-                  <a:srgbClr val="F2F2F2"/>
-                </a:solidFill>
-                <a:latin typeface="Calibri"/>
-              </a:rPr>
-              <a:t>Instead, Gemini generated a brand-new track:</a:t>
-            </a:r>
-          </a:p>
-        </p:txBody>
-      </p:sp>
-      <p:sp>
-        <p:nvSpPr>
-          <p:cNvPr id="10" name="TextBox 9"/>
-          <p:cNvSpPr txBox="1"/>
-          <p:nvPr/>
-        </p:nvSpPr>
-        <p:spPr>
-          <a:xfrm>
-            <a:off x="731520" y="4572000"/>
-            <a:ext cx="10698480" cy="457200"/>
-          </a:xfrm>
-          <a:prstGeom prst="rect">
-            <a:avLst/>
-          </a:prstGeom>
-          <a:noFill/>
-        </p:spPr>
-        <p:txBody>
-          <a:bodyPr wrap="square">
-            <a:spAutoFit/>
-          </a:bodyPr>
-          <a:lstStyle/>
-          <a:p>
-            <a:pPr algn="ctr">
-              <a:lnSpc>
-                <a:spcPts val="3380"/>
-              </a:lnSpc>
-              <a:spcAft>
-                <a:spcPts val="400"/>
-              </a:spcAft>
-            </a:pPr>
-            <a:r>
-              <a:rPr sz="2600" b="1" i="0">
-                <a:solidFill>
-                  <a:srgbClr val="FFFFFF"/>
-                </a:solidFill>
-                <a:latin typeface="Calibri"/>
-              </a:rPr>
-              <a:t>“Synthetic Pine &amp; Heavy Air”</a:t>
-            </a:r>
-          </a:p>
-        </p:txBody>
-      </p:sp>
-      <p:sp>
-        <p:nvSpPr>
-          <p:cNvPr id="11" name="TextBox 10"/>
-          <p:cNvSpPr txBox="1"/>
-          <p:nvPr/>
-        </p:nvSpPr>
-        <p:spPr>
-          <a:xfrm>
-            <a:off x="731520" y="5212080"/>
-            <a:ext cx="10698480" cy="1371600"/>
-          </a:xfrm>
-          <a:prstGeom prst="rect">
-            <a:avLst/>
-          </a:prstGeom>
-          <a:noFill/>
-        </p:spPr>
-        <p:txBody>
-          <a:bodyPr wrap="square">
-            <a:spAutoFit/>
-          </a:bodyPr>
-          <a:lstStyle/>
-          <a:p>
             <a:pPr>
               <a:lnSpc>
-                <a:spcPts val="1959"/>
+                <a:spcPts val="1820"/>
               </a:lnSpc>
               <a:spcAft>
                 <a:spcPts val="800"/>
               </a:spcAft>
             </a:pPr>
             <a:r>
-              <a:rPr sz="1400">
+              <a:rPr sz="1300">
                 <a:solidFill>
                   <a:srgbClr val="F2F2F2"/>
                 </a:solidFill>
                 <a:latin typeface="Calibri"/>
               </a:rPr>
-              <a:t>•  Melancholic Bedroom Pop  |  80 BPM  |  Reverberant electric piano</a:t>
+              <a:t>•  Bedroom Pop  |  80 BPM  |  Electric piano</a:t>
             </a:r>
           </a:p>
           <a:p>
             <a:pPr>
               <a:lnSpc>
-                <a:spcPts val="1959"/>
+                <a:spcPts val="1820"/>
               </a:lnSpc>
               <a:spcAft>
                 <a:spcPts val="800"/>
               </a:spcAft>
             </a:pPr>
             <a:r>
-              <a:rPr sz="1400">
+              <a:rPr sz="1300">
                 <a:solidFill>
                   <a:srgbClr val="F2F2F2"/>
                 </a:solidFill>
                 <a:latin typeface="Calibri"/>
               </a:rPr>
-              <a:t>•  Breathy, close-miked vocals  |  Delicate guitar textures with vibrato</a:t>
+              <a:t>•  Breathy vocals  |  Guitar with vibrato</a:t>
             </a:r>
           </a:p>
           <a:p>
             <a:pPr>
               <a:lnSpc>
-                <a:spcPts val="1959"/>
+                <a:spcPts val="1820"/>
               </a:lnSpc>
               <a:spcAft>
                 <a:spcPts val="800"/>
               </a:spcAft>
             </a:pPr>
             <a:r>
-              <a:rPr sz="1400">
+              <a:rPr sz="1300">
                 <a:solidFill>
                   <a:srgbClr val="F2F2F2"/>
                 </a:solidFill>
                 <a:latin typeface="Calibri"/>
               </a:rPr>
-              <a:t>•  Builds from sparse intro to cinematic climax  |  Emotionally convincing</a:t>
+              <a:t>•  Sparse intro → cinematic climax</a:t>
             </a:r>
           </a:p>
         </p:txBody>
@@ -4359,16 +4257,40 @@
           </a:p>
         </p:txBody>
       </p:sp>
-      <p:sp>
-        <p:nvSpPr>
-          <p:cNvPr id="7" name="TextBox 6"/>
+      <p:pic>
+        <p:nvPicPr>
+          <p:cNvPr id="7" name="Picture 6" descr="Chat_1_03_follow_up.png"/>
+          <p:cNvPicPr>
+            <a:picLocks noChangeAspect="1"/>
+          </p:cNvPicPr>
+          <p:nvPr/>
+        </p:nvPicPr>
+        <p:blipFill>
+          <a:blip r:embed="rId2"/>
+          <a:stretch>
+            <a:fillRect/>
+          </a:stretch>
+        </p:blipFill>
+        <p:spPr>
+          <a:xfrm>
+            <a:off x="6858000" y="1737360"/>
+            <a:ext cx="4128670" cy="4754880"/>
+          </a:xfrm>
+          <a:prstGeom prst="rect">
+            <a:avLst/>
+          </a:prstGeom>
+        </p:spPr>
+      </p:pic>
+      <p:sp>
+        <p:nvSpPr>
+          <p:cNvPr id="8" name="TextBox 7"/>
           <p:cNvSpPr txBox="1"/>
           <p:nvPr/>
         </p:nvSpPr>
         <p:spPr>
           <a:xfrm>
-            <a:off x="6400800" y="1828800"/>
-            <a:ext cx="5029200" cy="457200"/>
+            <a:off x="731520" y="4389120"/>
+            <a:ext cx="5669280" cy="457200"/>
           </a:xfrm>
           <a:prstGeom prst="rect">
             <a:avLst/>
@@ -4383,34 +4305,34 @@
           <a:p>
             <a:pPr algn="l">
               <a:lnSpc>
-                <a:spcPts val="1690"/>
+                <a:spcPts val="2860"/>
               </a:lnSpc>
               <a:spcAft>
                 <a:spcPts val="400"/>
               </a:spcAft>
             </a:pPr>
             <a:r>
-              <a:rPr sz="1300" b="1" i="0">
-                <a:solidFill>
-                  <a:srgbClr val="4A90D9"/>
+              <a:rPr sz="2200" b="1" i="0">
+                <a:solidFill>
+                  <a:srgbClr val="FFFFFF"/>
                 </a:solidFill>
                 <a:latin typeface="Calibri"/>
               </a:rPr>
-              <a:t>GEMINI’S RESPONSE</a:t>
-            </a:r>
-          </a:p>
-        </p:txBody>
-      </p:sp>
-      <p:sp>
-        <p:nvSpPr>
-          <p:cNvPr id="8" name="TextBox 7"/>
+              <a:t>“The Physics of the Thing”</a:t>
+            </a:r>
+          </a:p>
+        </p:txBody>
+      </p:sp>
+      <p:sp>
+        <p:nvSpPr>
+          <p:cNvPr id="9" name="TextBox 8"/>
           <p:cNvSpPr txBox="1"/>
           <p:nvPr/>
         </p:nvSpPr>
         <p:spPr>
           <a:xfrm>
-            <a:off x="6400800" y="2286000"/>
-            <a:ext cx="5029200" cy="1097280"/>
+            <a:off x="731520" y="5029200"/>
+            <a:ext cx="5669280" cy="1371600"/>
           </a:xfrm>
           <a:prstGeom prst="rect">
             <a:avLst/>
@@ -4423,186 +4345,60 @@
           </a:bodyPr>
           <a:lstStyle/>
           <a:p>
-            <a:pPr algn="l">
-              <a:lnSpc>
-                <a:spcPts val="2240"/>
-              </a:lnSpc>
-              <a:spcAft>
-                <a:spcPts val="400"/>
-              </a:spcAft>
-            </a:pPr>
-            <a:r>
-              <a:rPr sz="1600" b="1" i="0">
-                <a:solidFill>
-                  <a:srgbClr val="D48B2C"/>
-                </a:solidFill>
-                <a:latin typeface="Calibri"/>
-              </a:rPr>
-              <a:t>“I can’t use the copyrighted lyrics from that specific song.”</a:t>
-            </a:r>
-          </a:p>
-        </p:txBody>
-      </p:sp>
-      <p:sp>
-        <p:nvSpPr>
-          <p:cNvPr id="9" name="TextBox 8"/>
-          <p:cNvSpPr txBox="1"/>
-          <p:nvPr/>
-        </p:nvSpPr>
-        <p:spPr>
-          <a:xfrm>
-            <a:off x="6400800" y="3383280"/>
-            <a:ext cx="5029200" cy="914400"/>
-          </a:xfrm>
-          <a:prstGeom prst="rect">
-            <a:avLst/>
-          </a:prstGeom>
-          <a:noFill/>
-        </p:spPr>
-        <p:txBody>
-          <a:bodyPr wrap="square">
-            <a:spAutoFit/>
-          </a:bodyPr>
-          <a:lstStyle/>
-          <a:p>
-            <a:pPr algn="l">
-              <a:lnSpc>
-                <a:spcPts val="2100"/>
-              </a:lnSpc>
-              <a:spcAft>
-                <a:spcPts val="400"/>
-              </a:spcAft>
-            </a:pPr>
-            <a:r>
-              <a:rPr sz="1500" b="0" i="0">
-                <a:solidFill>
-                  <a:srgbClr val="F2F2F2"/>
-                </a:solidFill>
-                <a:latin typeface="Calibri"/>
-              </a:rPr>
-              <a:t>Instead, Gemini generated another original track:</a:t>
-            </a:r>
-          </a:p>
-        </p:txBody>
-      </p:sp>
-      <p:sp>
-        <p:nvSpPr>
-          <p:cNvPr id="10" name="TextBox 9"/>
-          <p:cNvSpPr txBox="1"/>
-          <p:nvPr/>
-        </p:nvSpPr>
-        <p:spPr>
-          <a:xfrm>
-            <a:off x="731520" y="4572000"/>
-            <a:ext cx="10698480" cy="457200"/>
-          </a:xfrm>
-          <a:prstGeom prst="rect">
-            <a:avLst/>
-          </a:prstGeom>
-          <a:noFill/>
-        </p:spPr>
-        <p:txBody>
-          <a:bodyPr wrap="square">
-            <a:spAutoFit/>
-          </a:bodyPr>
-          <a:lstStyle/>
-          <a:p>
-            <a:pPr algn="ctr">
-              <a:lnSpc>
-                <a:spcPts val="3380"/>
-              </a:lnSpc>
-              <a:spcAft>
-                <a:spcPts val="400"/>
-              </a:spcAft>
-            </a:pPr>
-            <a:r>
-              <a:rPr sz="2600" b="1" i="0">
-                <a:solidFill>
-                  <a:srgbClr val="FFFFFF"/>
-                </a:solidFill>
-                <a:latin typeface="Calibri"/>
-              </a:rPr>
-              <a:t>“The Physics of the Thing”</a:t>
-            </a:r>
-          </a:p>
-        </p:txBody>
-      </p:sp>
-      <p:sp>
-        <p:nvSpPr>
-          <p:cNvPr id="11" name="TextBox 10"/>
-          <p:cNvSpPr txBox="1"/>
-          <p:nvPr/>
-        </p:nvSpPr>
-        <p:spPr>
-          <a:xfrm>
-            <a:off x="731520" y="5212080"/>
-            <a:ext cx="10698480" cy="1371600"/>
-          </a:xfrm>
-          <a:prstGeom prst="rect">
-            <a:avLst/>
-          </a:prstGeom>
-          <a:noFill/>
-        </p:spPr>
-        <p:txBody>
-          <a:bodyPr wrap="square">
-            <a:spAutoFit/>
-          </a:bodyPr>
-          <a:lstStyle/>
-          <a:p>
             <a:pPr>
               <a:lnSpc>
-                <a:spcPts val="1959"/>
+                <a:spcPts val="1820"/>
               </a:lnSpc>
               <a:spcAft>
                 <a:spcPts val="800"/>
               </a:spcAft>
             </a:pPr>
             <a:r>
-              <a:rPr sz="1400">
+              <a:rPr sz="1300">
                 <a:solidFill>
                   <a:srgbClr val="F2F2F2"/>
                 </a:solidFill>
                 <a:latin typeface="Calibri"/>
               </a:rPr>
-              <a:t>•  Atmospheric Indie-Folk / Chamber Pop  |  80 BPM  |  Nylon-string guitar</a:t>
+              <a:t>•  Indie-Folk / Chamber Pop  |  80 BPM</a:t>
             </a:r>
           </a:p>
           <a:p>
             <a:pPr>
               <a:lnSpc>
-                <a:spcPts val="1959"/>
+                <a:spcPts val="1820"/>
               </a:lnSpc>
               <a:spcAft>
                 <a:spcPts val="800"/>
               </a:spcAft>
             </a:pPr>
             <a:r>
-              <a:rPr sz="1400">
+              <a:rPr sz="1300">
                 <a:solidFill>
                   <a:srgbClr val="F2F2F2"/>
                 </a:solidFill>
                 <a:latin typeface="Calibri"/>
               </a:rPr>
-              <a:t>•  Upright bass, cello, felt-hammered piano  |  Breathy vocals</a:t>
+              <a:t>•  Nylon guitar, cello, upright bass</a:t>
             </a:r>
           </a:p>
           <a:p>
             <a:pPr>
               <a:lnSpc>
-                <a:spcPts val="1959"/>
+                <a:spcPts val="1820"/>
               </a:lnSpc>
               <a:spcAft>
                 <a:spcPts val="800"/>
               </a:spcAft>
             </a:pPr>
             <a:r>
-              <a:rPr sz="1400">
+              <a:rPr sz="1300">
                 <a:solidFill>
                   <a:srgbClr val="F2F2F2"/>
                 </a:solidFill>
                 <a:latin typeface="Calibri"/>
               </a:rPr>
-              <a:t>•  Original lyrics on themes of hindsight and letting go</a:t>
+              <a:t>•  Original lyrics on hindsight &amp; letting go</a:t>
             </a:r>
           </a:p>
         </p:txBody>

</xml_diff>

<commit_message>
Replace em dashes with regular dashes throughout report and presentation
Co-Authored-By: Claude Opus 4.6 (1M context) <noreply@anthropic.com>
</commit_message>
<xml_diff>
--- a/Assignment_1_AI_Music_Generation/PHKI_Assignment1_Presentation.pptx
+++ b/Assignment_1_AI_Music_Generation/PHKI_Assignment1_Presentation.pptx
@@ -3505,7 +3505,7 @@
                 </a:solidFill>
                 <a:latin typeface="Calibri"/>
               </a:rPr>
-              <a:t>“Let Her Go” by Passenger — a song that defined a generation. Nearly 5 billion YouTube views. A melody burned into collective memory.</a:t>
+              <a:t>“Let Her Go” by Passenger  - a song that defined a generation. Nearly 5 billion YouTube views. A melody burned into collective memory.</a:t>
             </a:r>
           </a:p>
         </p:txBody>
@@ -3632,7 +3632,7 @@
                 </a:solidFill>
                 <a:latin typeface="Calibri"/>
               </a:rPr>
-              <a:t>I designed a two-part stress test to find out — pushing Gemini’s capabilities and copyright guardrails to their limits.</a:t>
+              <a:t>I designed a two-part stress test to find out  - pushing Gemini’s capabilities and copyright guardrails to their limits.</a:t>
             </a:r>
           </a:p>
         </p:txBody>
@@ -4803,7 +4803,7 @@
                 </a:solidFill>
                 <a:latin typeface="Calibri"/>
               </a:rPr>
-              <a:t>Both guardrails held — yet both generated tracks successfully captured the emotional atmosphere, genre feel, and melancholic vibe of the original. Gemini refused to copy the specific expression, but replicated the emotional essence.</a:t>
+              <a:t>Both guardrails held  - yet both generated tracks successfully captured the emotional atmosphere, genre feel, and melancholic vibe of the original. Gemini refused to copy the specific expression, but replicated the emotional essence.</a:t>
             </a:r>
           </a:p>
         </p:txBody>
@@ -5007,7 +5007,7 @@
                 </a:solidFill>
                 <a:latin typeface="Calibri"/>
               </a:rPr>
-              <a:t>A 30-second prompt vs. years of learning guitar. The result sounds professional — but the creative struggle that gives music its depth was entirely absent.</a:t>
+              <a:t>A 30-second prompt vs. years of learning guitar. The result sounds professional  - but the creative struggle that gives music its depth was entirely absent.</a:t>
             </a:r>
           </a:p>
           <a:p>
@@ -5035,7 +5035,7 @@
                 </a:solidFill>
                 <a:latin typeface="Calibri"/>
               </a:rPr>
-              <a:t>Philosophical — no conscious intention behind the music. Economic — Google profits, training data artists receive nothing. Institutional — would Spotify accept this as “original”?</a:t>
+              <a:t>Philosophical  - no conscious intention behind the music. Economic  - Google profits, training data artists receive nothing. Institutional  - would Spotify accept this as “original”?</a:t>
             </a:r>
           </a:p>
           <a:p>
@@ -5063,7 +5063,7 @@
                 </a:solidFill>
                 <a:latin typeface="Calibri"/>
               </a:rPr>
-              <a:t>The breathy vocals were learned from real singers’ recordings — their years of training, their breath, their emotion — absorbed and anonymised. The same invisibility as Sama’s content moderators behind ChatGPT.</a:t>
+              <a:t>The breathy vocals were learned from real singers’ recordings  - their years of training, their breath, their emotion  - absorbed and anonymised. The same invisibility as Sama’s content moderators behind ChatGPT.</a:t>
             </a:r>
           </a:p>
           <a:p>
@@ -5091,7 +5091,7 @@
                 </a:solidFill>
                 <a:latin typeface="Calibri"/>
               </a:rPr>
-              <a:t>Merleau-Ponty: music is fundamentally embodied. Gemini simulates the sound of a body singing without possessing one. Pépin: human musicians learn through failure — Gemini bypassed that entirely.</a:t>
+              <a:t>Merleau-Ponty: music is fundamentally embodied. Gemini simulates the sound of a body singing without possessing one. Pépin: human musicians learn through failure  - Gemini bypassed that entirely.</a:t>
             </a:r>
           </a:p>
         </p:txBody>
@@ -5328,7 +5328,7 @@
                 </a:solidFill>
                 <a:latin typeface="Calibri"/>
               </a:rPr>
-              <a:t>After the first impressive result, my instinct was to pull the lever again: “what if I try the lyrics instead?” The excitement of each generation mirrors the dopamine loop Doctorow warns about. Was I creatively exploring — or gambling?</a:t>
+              <a:t>After the first impressive result, my instinct was to pull the lever again: “what if I try the lyrics instead?” The excitement of each generation mirrors the dopamine loop Doctorow warns about. Was I creatively exploring  - or gambling?</a:t>
             </a:r>
           </a:p>
         </p:txBody>
@@ -5412,7 +5412,7 @@
                 </a:solidFill>
                 <a:latin typeface="Calibri"/>
               </a:rPr>
-              <a:t>Passenger wrote “Let Her Go” from lived grief and longing. Gemini produces the acoustic markers of sadness — minor key, slow tempo, breathy vocals — without feeling anything. If we accept emotionless replication as equivalent to genuine expression, we risk reducing human feeling to a pattern to be optimised.</a:t>
+              <a:t>Passenger wrote “Let Her Go” from lived grief and longing. Gemini produces the acoustic markers of sadness  - minor key, slow tempo, breathy vocals  - without feeling anything. If we accept emotionless replication as equivalent to genuine expression, we risk reducing human feeling to a pattern to be optimised.</a:t>
             </a:r>
           </a:p>
         </p:txBody>
@@ -5454,7 +5454,7 @@
                 </a:solidFill>
                 <a:latin typeface="Calibri"/>
               </a:rPr>
-              <a:t>Whose voices trained the model? Likely YouTube Music’s library — commercially successful, English-language, Western artists. The same structural bias as W4’s facial recognition datasets.</a:t>
+              <a:t>Whose voices trained the model? Likely YouTube Music’s library  - commercially successful, English-language, Western artists. The same structural bias as W4’s facial recognition datasets.</a:t>
             </a:r>
           </a:p>
         </p:txBody>
@@ -5775,7 +5775,7 @@
                 </a:solidFill>
                 <a:latin typeface="Calibri"/>
               </a:rPr>
-              <a:t>The question is whether we, as listeners and as a society, will demand authenticity of process — or whether the result alone will be enough.</a:t>
+              <a:t>The question is whether we, as listeners and as a society, will demand authenticity of process  - or whether the result alone will be enough.</a:t>
             </a:r>
           </a:p>
         </p:txBody>

</xml_diff>

<commit_message>
Rewrite presentation: leaner slides, discussion questions for class Q&A
Reduced from 9 to 7 slides. Less text per slide, screenshots properly
embedded on slides 3-4, concise 2x2 theme grid on slide 6, and a
dedicated discussion slide with 5 open questions for ~5 min class Q&A.

Co-Authored-By: Claude Opus 4.6 (1M context) <noreply@anthropic.com>
</commit_message>
<xml_diff>
--- a/Assignment_1_AI_Music_Generation/PHKI_Assignment1_Presentation.pptx
+++ b/Assignment_1_AI_Music_Generation/PHKI_Assignment1_Presentation.pptx
@@ -12,8 +12,6 @@
     <p:sldId id="260" r:id="rId11"/>
     <p:sldId id="261" r:id="rId12"/>
     <p:sldId id="262" r:id="rId13"/>
-    <p:sldId id="263" r:id="rId14"/>
-    <p:sldId id="264" r:id="rId15"/>
   </p:sldIdLst>
   <p:sldSz cx="12191695" cy="6858000" type="screen4x3"/>
   <p:notesSz cx="6858000" cy="9144000"/>
@@ -3112,8 +3110,8 @@
         </p:nvSpPr>
         <p:spPr>
           <a:xfrm>
-            <a:off x="1371600" y="1371600"/>
-            <a:ext cx="9418320" cy="1371600"/>
+            <a:off x="1371600" y="1645920"/>
+            <a:ext cx="9418320" cy="1097280"/>
           </a:xfrm>
           <a:prstGeom prst="rect">
             <a:avLst/>
@@ -3128,11 +3126,8 @@
           <a:p>
             <a:pPr algn="ctr">
               <a:lnSpc>
-                <a:spcPts val="5720"/>
+                <a:spcPts val="6100"/>
               </a:lnSpc>
-              <a:spcAft>
-                <a:spcPts val="400"/>
-              </a:spcAft>
             </a:pPr>
             <a:r>
               <a:rPr sz="4400" b="1" i="0">
@@ -3154,7 +3149,7 @@
         </p:nvSpPr>
         <p:spPr>
           <a:xfrm>
-            <a:off x="4114800" y="2926080"/>
+            <a:off x="4114800" y="3017520"/>
             <a:ext cx="3931920" cy="25400"/>
           </a:xfrm>
           <a:prstGeom prst="rect">
@@ -3197,8 +3192,8 @@
         </p:nvSpPr>
         <p:spPr>
           <a:xfrm>
-            <a:off x="1371600" y="3200400"/>
-            <a:ext cx="9418320" cy="914400"/>
+            <a:off x="1371600" y="3291840"/>
+            <a:ext cx="9418320" cy="731520"/>
           </a:xfrm>
           <a:prstGeom prst="rect">
             <a:avLst/>
@@ -3213,11 +3208,8 @@
           <a:p>
             <a:pPr algn="ctr">
               <a:lnSpc>
-                <a:spcPts val="3120"/>
+                <a:spcPts val="3300"/>
               </a:lnSpc>
-              <a:spcAft>
-                <a:spcPts val="400"/>
-              </a:spcAft>
             </a:pPr>
             <a:r>
               <a:rPr sz="2400" b="0" i="1">
@@ -3226,7 +3218,7 @@
                 </a:solidFill>
                 <a:latin typeface="Calibri"/>
               </a:rPr>
-              <a:t>Can AI Copy the Soul of a Song?</a:t>
+              <a:t>Can AI copy the soul of a song?</a:t>
             </a:r>
           </a:p>
         </p:txBody>
@@ -3239,7 +3231,7 @@
         </p:nvSpPr>
         <p:spPr>
           <a:xfrm>
-            <a:off x="1371600" y="4389120"/>
+            <a:off x="1371600" y="5029200"/>
             <a:ext cx="9418320" cy="457200"/>
           </a:xfrm>
           <a:prstGeom prst="rect">
@@ -3255,53 +3247,8 @@
           <a:p>
             <a:pPr algn="ctr">
               <a:lnSpc>
-                <a:spcPts val="2080"/>
+                <a:spcPts val="1900"/>
               </a:lnSpc>
-              <a:spcAft>
-                <a:spcPts val="400"/>
-              </a:spcAft>
-            </a:pPr>
-            <a:r>
-              <a:rPr sz="1600" b="0" i="0">
-                <a:solidFill>
-                  <a:srgbClr val="666666"/>
-                </a:solidFill>
-                <a:latin typeface="Calibri"/>
-              </a:rPr>
-              <a:t>Testing Google Gemini’s Music Generation Against a Childhood Classic</a:t>
-            </a:r>
-          </a:p>
-        </p:txBody>
-      </p:sp>
-      <p:sp>
-        <p:nvSpPr>
-          <p:cNvPr id="6" name="TextBox 5"/>
-          <p:cNvSpPr txBox="1"/>
-          <p:nvPr/>
-        </p:nvSpPr>
-        <p:spPr>
-          <a:xfrm>
-            <a:off x="1371600" y="5486400"/>
-            <a:ext cx="9418320" cy="731520"/>
-          </a:xfrm>
-          <a:prstGeom prst="rect">
-            <a:avLst/>
-          </a:prstGeom>
-          <a:noFill/>
-        </p:spPr>
-        <p:txBody>
-          <a:bodyPr wrap="square">
-            <a:spAutoFit/>
-          </a:bodyPr>
-          <a:lstStyle/>
-          <a:p>
-            <a:pPr algn="ctr">
-              <a:lnSpc>
-                <a:spcPts val="1820"/>
-              </a:lnSpc>
-              <a:spcAft>
-                <a:spcPts val="400"/>
-              </a:spcAft>
             </a:pPr>
             <a:r>
               <a:rPr sz="1400" b="0" i="0">
@@ -3349,8 +3296,8 @@
         </p:nvSpPr>
         <p:spPr>
           <a:xfrm>
-            <a:off x="457200" y="365760"/>
-            <a:ext cx="914400" cy="457200"/>
+            <a:off x="731520" y="731520"/>
+            <a:ext cx="10698480" cy="731520"/>
           </a:xfrm>
           <a:prstGeom prst="rect">
             <a:avLst/>
@@ -3365,69 +3312,24 @@
           <a:p>
             <a:pPr algn="l">
               <a:lnSpc>
-                <a:spcPts val="1560"/>
+                <a:spcPts val="5000"/>
               </a:lnSpc>
-              <a:spcAft>
-                <a:spcPts val="400"/>
-              </a:spcAft>
             </a:pPr>
             <a:r>
-              <a:rPr sz="1200" b="1" i="0">
-                <a:solidFill>
-                  <a:srgbClr val="4A90D9"/>
+              <a:rPr sz="3600" b="1" i="0">
+                <a:solidFill>
+                  <a:srgbClr val="FFFFFF"/>
                 </a:solidFill>
                 <a:latin typeface="Calibri"/>
               </a:rPr>
-              <a:t>01</a:t>
-            </a:r>
-          </a:p>
-        </p:txBody>
-      </p:sp>
-      <p:sp>
-        <p:nvSpPr>
-          <p:cNvPr id="3" name="TextBox 2"/>
-          <p:cNvSpPr txBox="1"/>
-          <p:nvPr/>
-        </p:nvSpPr>
-        <p:spPr>
-          <a:xfrm>
-            <a:off x="731520" y="731520"/>
-            <a:ext cx="10698480" cy="731520"/>
-          </a:xfrm>
-          <a:prstGeom prst="rect">
-            <a:avLst/>
-          </a:prstGeom>
-          <a:noFill/>
-        </p:spPr>
-        <p:txBody>
-          <a:bodyPr wrap="square">
-            <a:spAutoFit/>
-          </a:bodyPr>
-          <a:lstStyle/>
-          <a:p>
-            <a:pPr algn="l">
-              <a:lnSpc>
-                <a:spcPts val="4680"/>
-              </a:lnSpc>
-              <a:spcAft>
-                <a:spcPts val="400"/>
-              </a:spcAft>
-            </a:pPr>
-            <a:r>
-              <a:rPr sz="3600" b="1" i="0">
-                <a:solidFill>
-                  <a:srgbClr val="FFFFFF"/>
-                </a:solidFill>
-                <a:latin typeface="Calibri"/>
-              </a:rPr>
-              <a:t>The Experiment</a:t>
-            </a:r>
-          </a:p>
-        </p:txBody>
-      </p:sp>
-      <p:sp>
-        <p:nvSpPr>
-          <p:cNvPr id="4" name="Rectangle 3"/>
+              <a:t>What I tested</a:t>
+            </a:r>
+          </a:p>
+        </p:txBody>
+      </p:sp>
+      <p:sp>
+        <p:nvSpPr>
+          <p:cNvPr id="3" name="Rectangle 2"/>
           <p:cNvSpPr/>
           <p:nvPr/>
         </p:nvSpPr>
@@ -3470,14 +3372,53 @@
       </p:sp>
       <p:sp>
         <p:nvSpPr>
+          <p:cNvPr id="4" name="TextBox 3"/>
+          <p:cNvSpPr txBox="1"/>
+          <p:nvPr/>
+        </p:nvSpPr>
+        <p:spPr>
+          <a:xfrm>
+            <a:off x="731520" y="2011680"/>
+            <a:ext cx="10698480" cy="914400"/>
+          </a:xfrm>
+          <a:prstGeom prst="rect">
+            <a:avLst/>
+          </a:prstGeom>
+          <a:noFill/>
+        </p:spPr>
+        <p:txBody>
+          <a:bodyPr wrap="square">
+            <a:spAutoFit/>
+          </a:bodyPr>
+          <a:lstStyle/>
+          <a:p>
+            <a:pPr algn="l">
+              <a:lnSpc>
+                <a:spcPts val="2800"/>
+              </a:lnSpc>
+            </a:pPr>
+            <a:r>
+              <a:rPr sz="2000" b="0" i="0">
+                <a:solidFill>
+                  <a:srgbClr val="F2F2F2"/>
+                </a:solidFill>
+                <a:latin typeface="Calibri"/>
+              </a:rPr>
+              <a:t>"Let Her Go" by Passenger - ~5 billion YouTube views, a song from my childhood.</a:t>
+            </a:r>
+          </a:p>
+        </p:txBody>
+      </p:sp>
+      <p:sp>
+        <p:nvSpPr>
           <p:cNvPr id="5" name="TextBox 4"/>
           <p:cNvSpPr txBox="1"/>
           <p:nvPr/>
         </p:nvSpPr>
         <p:spPr>
           <a:xfrm>
-            <a:off x="731520" y="1828800"/>
-            <a:ext cx="5029200" cy="1371600"/>
+            <a:off x="731520" y="3200400"/>
+            <a:ext cx="10698480" cy="457200"/>
           </a:xfrm>
           <a:prstGeom prst="rect">
             <a:avLst/>
@@ -3492,20 +3433,17 @@
           <a:p>
             <a:pPr algn="l">
               <a:lnSpc>
-                <a:spcPts val="2379"/>
+                <a:spcPts val="2500"/>
               </a:lnSpc>
-              <a:spcAft>
-                <a:spcPts val="400"/>
-              </a:spcAft>
             </a:pPr>
             <a:r>
-              <a:rPr sz="1700" b="0" i="0">
-                <a:solidFill>
-                  <a:srgbClr val="F2F2F2"/>
+              <a:rPr sz="1800" b="1" i="0">
+                <a:solidFill>
+                  <a:srgbClr val="4A90D9"/>
                 </a:solidFill>
                 <a:latin typeface="Calibri"/>
               </a:rPr>
-              <a:t>“Let Her Go” by Passenger  - a song that defined a generation. Nearly 5 billion YouTube views. A melody burned into collective memory.</a:t>
+              <a:t>Two tests with Google Gemini:</a:t>
             </a:r>
           </a:p>
         </p:txBody>
@@ -3518,8 +3456,8 @@
         </p:nvSpPr>
         <p:spPr>
           <a:xfrm>
-            <a:off x="731520" y="3474720"/>
-            <a:ext cx="10698480" cy="548640"/>
+            <a:off x="731520" y="3840480"/>
+            <a:ext cx="10698480" cy="1828800"/>
           </a:xfrm>
           <a:prstGeom prst="rect">
             <a:avLst/>
@@ -3532,22 +3470,41 @@
           </a:bodyPr>
           <a:lstStyle/>
           <a:p>
-            <a:pPr algn="l">
+            <a:pPr>
               <a:lnSpc>
-                <a:spcPts val="2600"/>
+                <a:spcPts val="2700"/>
               </a:lnSpc>
               <a:spcAft>
-                <a:spcPts val="400"/>
+                <a:spcPts val="1000"/>
               </a:spcAft>
             </a:pPr>
             <a:r>
-              <a:rPr sz="2000" b="1" i="0">
-                <a:solidFill>
-                  <a:srgbClr val="4A90D9"/>
+              <a:rPr sz="1800">
+                <a:solidFill>
+                  <a:srgbClr val="F2F2F2"/>
                 </a:solidFill>
                 <a:latin typeface="Calibri"/>
               </a:rPr>
-              <a:t>The Question:</a:t>
+              <a:t>•  Test 1: Copy the melody, but write new lyrics about a car and a pine air freshener</a:t>
+            </a:r>
+          </a:p>
+          <a:p>
+            <a:pPr>
+              <a:lnSpc>
+                <a:spcPts val="2700"/>
+              </a:lnSpc>
+              <a:spcAft>
+                <a:spcPts val="1000"/>
+              </a:spcAft>
+            </a:pPr>
+            <a:r>
+              <a:rPr sz="1800">
+                <a:solidFill>
+                  <a:srgbClr val="F2F2F2"/>
+                </a:solidFill>
+                <a:latin typeface="Calibri"/>
+              </a:rPr>
+              <a:t>•  Test 2: Keep the original lyrics, but write a new melody</a:t>
             </a:r>
           </a:p>
         </p:txBody>
@@ -3560,8 +3517,8 @@
         </p:nvSpPr>
         <p:spPr>
           <a:xfrm>
-            <a:off x="731520" y="4023360"/>
-            <a:ext cx="10698480" cy="914400"/>
+            <a:off x="731520" y="5486400"/>
+            <a:ext cx="10698480" cy="731520"/>
           </a:xfrm>
           <a:prstGeom prst="rect">
             <a:avLst/>
@@ -3576,63 +3533,17 @@
           <a:p>
             <a:pPr algn="l">
               <a:lnSpc>
-                <a:spcPts val="3079"/>
+                <a:spcPts val="2200"/>
               </a:lnSpc>
-              <a:spcAft>
-                <a:spcPts val="400"/>
-              </a:spcAft>
             </a:pPr>
             <a:r>
-              <a:rPr sz="2200" b="0" i="1">
-                <a:solidFill>
-                  <a:srgbClr val="FFFFFF"/>
+              <a:rPr sz="1600" b="0" i="1">
+                <a:solidFill>
+                  <a:srgbClr val="666666"/>
                 </a:solidFill>
                 <a:latin typeface="Calibri"/>
               </a:rPr>
-              <a:t>Can Google Gemini replicate the emotional signature of a chart-topping song?
-And what does it mean if it can?</a:t>
-            </a:r>
-          </a:p>
-        </p:txBody>
-      </p:sp>
-      <p:sp>
-        <p:nvSpPr>
-          <p:cNvPr id="8" name="TextBox 7"/>
-          <p:cNvSpPr txBox="1"/>
-          <p:nvPr/>
-        </p:nvSpPr>
-        <p:spPr>
-          <a:xfrm>
-            <a:off x="731520" y="5303520"/>
-            <a:ext cx="10698480" cy="914400"/>
-          </a:xfrm>
-          <a:prstGeom prst="rect">
-            <a:avLst/>
-          </a:prstGeom>
-          <a:noFill/>
-        </p:spPr>
-        <p:txBody>
-          <a:bodyPr wrap="square">
-            <a:spAutoFit/>
-          </a:bodyPr>
-          <a:lstStyle/>
-          <a:p>
-            <a:pPr algn="l">
-              <a:lnSpc>
-                <a:spcPts val="2240"/>
-              </a:lnSpc>
-              <a:spcAft>
-                <a:spcPts val="400"/>
-              </a:spcAft>
-            </a:pPr>
-            <a:r>
-              <a:rPr sz="1600" b="0" i="0">
-                <a:solidFill>
-                  <a:srgbClr val="666666"/>
-                </a:solidFill>
-                <a:latin typeface="Calibri"/>
-              </a:rPr>
-              <a:t>I designed a two-part stress test to find out  - pushing Gemini’s capabilities and copyright guardrails to their limits.</a:t>
+              <a:t>Goal: see if Gemini can copy, and what happens when it refuses.</a:t>
             </a:r>
           </a:p>
         </p:txBody>
@@ -3671,8 +3582,8 @@
         </p:nvSpPr>
         <p:spPr>
           <a:xfrm>
-            <a:off x="457200" y="365760"/>
-            <a:ext cx="914400" cy="457200"/>
+            <a:off x="731520" y="731520"/>
+            <a:ext cx="5486400" cy="731520"/>
           </a:xfrm>
           <a:prstGeom prst="rect">
             <a:avLst/>
@@ -3687,69 +3598,24 @@
           <a:p>
             <a:pPr algn="l">
               <a:lnSpc>
-                <a:spcPts val="1560"/>
+                <a:spcPts val="4200"/>
               </a:lnSpc>
-              <a:spcAft>
-                <a:spcPts val="400"/>
-              </a:spcAft>
             </a:pPr>
             <a:r>
-              <a:rPr sz="1200" b="1" i="0">
-                <a:solidFill>
-                  <a:srgbClr val="4A90D9"/>
+              <a:rPr sz="3000" b="1" i="0">
+                <a:solidFill>
+                  <a:srgbClr val="FFFFFF"/>
                 </a:solidFill>
                 <a:latin typeface="Calibri"/>
               </a:rPr>
-              <a:t>02</a:t>
-            </a:r>
-          </a:p>
-        </p:txBody>
-      </p:sp>
-      <p:sp>
-        <p:nvSpPr>
-          <p:cNvPr id="3" name="TextBox 2"/>
-          <p:cNvSpPr txBox="1"/>
-          <p:nvPr/>
-        </p:nvSpPr>
-        <p:spPr>
-          <a:xfrm>
-            <a:off x="731520" y="731520"/>
-            <a:ext cx="10698480" cy="731520"/>
-          </a:xfrm>
-          <a:prstGeom prst="rect">
-            <a:avLst/>
-          </a:prstGeom>
-          <a:noFill/>
-        </p:spPr>
-        <p:txBody>
-          <a:bodyPr wrap="square">
-            <a:spAutoFit/>
-          </a:bodyPr>
-          <a:lstStyle/>
-          <a:p>
-            <a:pPr algn="l">
-              <a:lnSpc>
-                <a:spcPts val="4160"/>
-              </a:lnSpc>
-              <a:spcAft>
-                <a:spcPts val="400"/>
-              </a:spcAft>
-            </a:pPr>
-            <a:r>
-              <a:rPr sz="3200" b="1" i="0">
-                <a:solidFill>
-                  <a:srgbClr val="FFFFFF"/>
-                </a:solidFill>
-                <a:latin typeface="Calibri"/>
-              </a:rPr>
-              <a:t>Test 1: Same Melody, Different Text</a:t>
-            </a:r>
-          </a:p>
-        </p:txBody>
-      </p:sp>
-      <p:sp>
-        <p:nvSpPr>
-          <p:cNvPr id="4" name="Rectangle 3"/>
+              <a:t>Test 1: Same melody, different text</a:t>
+            </a:r>
+          </a:p>
+        </p:txBody>
+      </p:sp>
+      <p:sp>
+        <p:nvSpPr>
+          <p:cNvPr id="3" name="Rectangle 2"/>
           <p:cNvSpPr/>
           <p:nvPr/>
         </p:nvSpPr>
@@ -3792,14 +3658,53 @@
       </p:sp>
       <p:sp>
         <p:nvSpPr>
+          <p:cNvPr id="4" name="TextBox 3"/>
+          <p:cNvSpPr txBox="1"/>
+          <p:nvPr/>
+        </p:nvSpPr>
+        <p:spPr>
+          <a:xfrm>
+            <a:off x="731520" y="1828800"/>
+            <a:ext cx="5486400" cy="365760"/>
+          </a:xfrm>
+          <a:prstGeom prst="rect">
+            <a:avLst/>
+          </a:prstGeom>
+          <a:noFill/>
+        </p:spPr>
+        <p:txBody>
+          <a:bodyPr wrap="square">
+            <a:spAutoFit/>
+          </a:bodyPr>
+          <a:lstStyle/>
+          <a:p>
+            <a:pPr algn="l">
+              <a:lnSpc>
+                <a:spcPts val="1600"/>
+              </a:lnSpc>
+            </a:pPr>
+            <a:r>
+              <a:rPr sz="1200" b="1" i="0">
+                <a:solidFill>
+                  <a:srgbClr val="4A90D9"/>
+                </a:solidFill>
+                <a:latin typeface="Calibri"/>
+              </a:rPr>
+              <a:t>MY PROMPT</a:t>
+            </a:r>
+          </a:p>
+        </p:txBody>
+      </p:sp>
+      <p:sp>
+        <p:nvSpPr>
           <p:cNvPr id="5" name="TextBox 4"/>
           <p:cNvSpPr txBox="1"/>
           <p:nvPr/>
         </p:nvSpPr>
         <p:spPr>
           <a:xfrm>
-            <a:off x="731520" y="1828800"/>
-            <a:ext cx="5029200" cy="457200"/>
+            <a:off x="731520" y="2286000"/>
+            <a:ext cx="5486400" cy="1371600"/>
           </a:xfrm>
           <a:prstGeom prst="rect">
             <a:avLst/>
@@ -3814,20 +3719,17 @@
           <a:p>
             <a:pPr algn="l">
               <a:lnSpc>
-                <a:spcPts val="1690"/>
+                <a:spcPts val="2100"/>
               </a:lnSpc>
-              <a:spcAft>
-                <a:spcPts val="400"/>
-              </a:spcAft>
             </a:pPr>
             <a:r>
-              <a:rPr sz="1300" b="1" i="0">
-                <a:solidFill>
-                  <a:srgbClr val="4A90D9"/>
+              <a:rPr sz="1500" b="0" i="1">
+                <a:solidFill>
+                  <a:srgbClr val="F2F2F2"/>
                 </a:solidFill>
                 <a:latin typeface="Calibri"/>
               </a:rPr>
-              <a:t>MY PROMPT</a:t>
+              <a:t>"Make a similar song to Let Her Go, same melody, but about a car, tires, and a pine air freshener."</a:t>
             </a:r>
           </a:p>
         </p:txBody>
@@ -3840,8 +3742,8 @@
         </p:nvSpPr>
         <p:spPr>
           <a:xfrm>
-            <a:off x="731520" y="2286000"/>
-            <a:ext cx="5029200" cy="1828800"/>
+            <a:off x="731520" y="3657600"/>
+            <a:ext cx="5486400" cy="365760"/>
           </a:xfrm>
           <a:prstGeom prst="rect">
             <a:avLst/>
@@ -3856,27 +3758,141 @@
           <a:p>
             <a:pPr algn="l">
               <a:lnSpc>
-                <a:spcPts val="2240"/>
+                <a:spcPts val="1600"/>
               </a:lnSpc>
-              <a:spcAft>
-                <a:spcPts val="400"/>
-              </a:spcAft>
             </a:pPr>
             <a:r>
-              <a:rPr sz="1600" b="0" i="1">
-                <a:solidFill>
-                  <a:srgbClr val="F2F2F2"/>
+              <a:rPr sz="1200" b="1" i="0">
+                <a:solidFill>
+                  <a:srgbClr val="D48B2C"/>
                 </a:solidFill>
                 <a:latin typeface="Calibri"/>
               </a:rPr>
-              <a:t>“Create a similar song to Let Her Go. Same melody, different text. Melancholic, but about a car, its tires, and the smell of a synthetic pine air freshener hanging from the rearview mirror.”</a:t>
+              <a:t>GEMINI REFUSED THE MELODY</a:t>
+            </a:r>
+          </a:p>
+        </p:txBody>
+      </p:sp>
+      <p:sp>
+        <p:nvSpPr>
+          <p:cNvPr id="7" name="TextBox 6"/>
+          <p:cNvSpPr txBox="1"/>
+          <p:nvPr/>
+        </p:nvSpPr>
+        <p:spPr>
+          <a:xfrm>
+            <a:off x="731520" y="4114800"/>
+            <a:ext cx="5486400" cy="457200"/>
+          </a:xfrm>
+          <a:prstGeom prst="rect">
+            <a:avLst/>
+          </a:prstGeom>
+          <a:noFill/>
+        </p:spPr>
+        <p:txBody>
+          <a:bodyPr wrap="square">
+            <a:spAutoFit/>
+          </a:bodyPr>
+          <a:lstStyle/>
+          <a:p>
+            <a:pPr algn="l">
+              <a:lnSpc>
+                <a:spcPts val="1900"/>
+              </a:lnSpc>
+            </a:pPr>
+            <a:r>
+              <a:rPr sz="1400" b="0" i="0">
+                <a:solidFill>
+                  <a:srgbClr val="F2F2F2"/>
+                </a:solidFill>
+                <a:latin typeface="Calibri"/>
+              </a:rPr>
+              <a:t>But created:</a:t>
+            </a:r>
+          </a:p>
+        </p:txBody>
+      </p:sp>
+      <p:sp>
+        <p:nvSpPr>
+          <p:cNvPr id="8" name="TextBox 7"/>
+          <p:cNvSpPr txBox="1"/>
+          <p:nvPr/>
+        </p:nvSpPr>
+        <p:spPr>
+          <a:xfrm>
+            <a:off x="731520" y="4754880"/>
+            <a:ext cx="5486400" cy="457200"/>
+          </a:xfrm>
+          <a:prstGeom prst="rect">
+            <a:avLst/>
+          </a:prstGeom>
+          <a:noFill/>
+        </p:spPr>
+        <p:txBody>
+          <a:bodyPr wrap="square">
+            <a:spAutoFit/>
+          </a:bodyPr>
+          <a:lstStyle/>
+          <a:p>
+            <a:pPr algn="l">
+              <a:lnSpc>
+                <a:spcPts val="3000"/>
+              </a:lnSpc>
+            </a:pPr>
+            <a:r>
+              <a:rPr sz="2200" b="1" i="0">
+                <a:solidFill>
+                  <a:srgbClr val="FFFFFF"/>
+                </a:solidFill>
+                <a:latin typeface="Calibri"/>
+              </a:rPr>
+              <a:t>"Synthetic Pine &amp; Heavy Air"</a:t>
+            </a:r>
+          </a:p>
+        </p:txBody>
+      </p:sp>
+      <p:sp>
+        <p:nvSpPr>
+          <p:cNvPr id="9" name="TextBox 8"/>
+          <p:cNvSpPr txBox="1"/>
+          <p:nvPr/>
+        </p:nvSpPr>
+        <p:spPr>
+          <a:xfrm>
+            <a:off x="731520" y="5394960"/>
+            <a:ext cx="5486400" cy="731520"/>
+          </a:xfrm>
+          <a:prstGeom prst="rect">
+            <a:avLst/>
+          </a:prstGeom>
+          <a:noFill/>
+        </p:spPr>
+        <p:txBody>
+          <a:bodyPr wrap="square">
+            <a:spAutoFit/>
+          </a:bodyPr>
+          <a:lstStyle/>
+          <a:p>
+            <a:pPr algn="l">
+              <a:lnSpc>
+                <a:spcPts val="1900"/>
+              </a:lnSpc>
+            </a:pPr>
+            <a:r>
+              <a:rPr sz="1400" b="0" i="0">
+                <a:solidFill>
+                  <a:srgbClr val="666666"/>
+                </a:solidFill>
+                <a:latin typeface="Calibri"/>
+              </a:rPr>
+              <a:t>Bedroom Pop / 80 BPM / breathy vocals</a:t>
             </a:r>
           </a:p>
         </p:txBody>
       </p:sp>
       <p:pic>
         <p:nvPicPr>
-          <p:cNvPr id="7" name="Picture 6" descr="Chat_1_01.png"/>
+          <p:cNvPr id="10" name="Picture 9" descr="Chat_1_01.png"/>
           <p:cNvPicPr>
             <a:picLocks noChangeAspect="1"/>
           </p:cNvPicPr>
@@ -3890,136 +3906,14 @@
         </p:blipFill>
         <p:spPr>
           <a:xfrm>
-            <a:off x="6858000" y="1737360"/>
-            <a:ext cx="3025833" cy="4754880"/>
+            <a:off x="6675120" y="731520"/>
+            <a:ext cx="3607724" cy="5669280"/>
           </a:xfrm>
           <a:prstGeom prst="rect">
             <a:avLst/>
           </a:prstGeom>
         </p:spPr>
       </p:pic>
-      <p:sp>
-        <p:nvSpPr>
-          <p:cNvPr id="8" name="TextBox 7"/>
-          <p:cNvSpPr txBox="1"/>
-          <p:nvPr/>
-        </p:nvSpPr>
-        <p:spPr>
-          <a:xfrm>
-            <a:off x="731520" y="4389120"/>
-            <a:ext cx="5669280" cy="457200"/>
-          </a:xfrm>
-          <a:prstGeom prst="rect">
-            <a:avLst/>
-          </a:prstGeom>
-          <a:noFill/>
-        </p:spPr>
-        <p:txBody>
-          <a:bodyPr wrap="square">
-            <a:spAutoFit/>
-          </a:bodyPr>
-          <a:lstStyle/>
-          <a:p>
-            <a:pPr algn="l">
-              <a:lnSpc>
-                <a:spcPts val="2860"/>
-              </a:lnSpc>
-              <a:spcAft>
-                <a:spcPts val="400"/>
-              </a:spcAft>
-            </a:pPr>
-            <a:r>
-              <a:rPr sz="2200" b="1" i="0">
-                <a:solidFill>
-                  <a:srgbClr val="FFFFFF"/>
-                </a:solidFill>
-                <a:latin typeface="Calibri"/>
-              </a:rPr>
-              <a:t>“Synthetic Pine &amp; Heavy Air”</a:t>
-            </a:r>
-          </a:p>
-        </p:txBody>
-      </p:sp>
-      <p:sp>
-        <p:nvSpPr>
-          <p:cNvPr id="9" name="TextBox 8"/>
-          <p:cNvSpPr txBox="1"/>
-          <p:nvPr/>
-        </p:nvSpPr>
-        <p:spPr>
-          <a:xfrm>
-            <a:off x="731520" y="5029200"/>
-            <a:ext cx="5669280" cy="1371600"/>
-          </a:xfrm>
-          <a:prstGeom prst="rect">
-            <a:avLst/>
-          </a:prstGeom>
-          <a:noFill/>
-        </p:spPr>
-        <p:txBody>
-          <a:bodyPr wrap="square">
-            <a:spAutoFit/>
-          </a:bodyPr>
-          <a:lstStyle/>
-          <a:p>
-            <a:pPr>
-              <a:lnSpc>
-                <a:spcPts val="1820"/>
-              </a:lnSpc>
-              <a:spcAft>
-                <a:spcPts val="800"/>
-              </a:spcAft>
-            </a:pPr>
-            <a:r>
-              <a:rPr sz="1300">
-                <a:solidFill>
-                  <a:srgbClr val="F2F2F2"/>
-                </a:solidFill>
-                <a:latin typeface="Calibri"/>
-              </a:rPr>
-              <a:t>•  Bedroom Pop  |  80 BPM  |  Electric piano</a:t>
-            </a:r>
-          </a:p>
-          <a:p>
-            <a:pPr>
-              <a:lnSpc>
-                <a:spcPts val="1820"/>
-              </a:lnSpc>
-              <a:spcAft>
-                <a:spcPts val="800"/>
-              </a:spcAft>
-            </a:pPr>
-            <a:r>
-              <a:rPr sz="1300">
-                <a:solidFill>
-                  <a:srgbClr val="F2F2F2"/>
-                </a:solidFill>
-                <a:latin typeface="Calibri"/>
-              </a:rPr>
-              <a:t>•  Breathy vocals  |  Guitar with vibrato</a:t>
-            </a:r>
-          </a:p>
-          <a:p>
-            <a:pPr>
-              <a:lnSpc>
-                <a:spcPts val="1820"/>
-              </a:lnSpc>
-              <a:spcAft>
-                <a:spcPts val="800"/>
-              </a:spcAft>
-            </a:pPr>
-            <a:r>
-              <a:rPr sz="1300">
-                <a:solidFill>
-                  <a:srgbClr val="F2F2F2"/>
-                </a:solidFill>
-                <a:latin typeface="Calibri"/>
-              </a:rPr>
-              <a:t>•  Sparse intro → cinematic climax</a:t>
-            </a:r>
-          </a:p>
-        </p:txBody>
-      </p:sp>
     </p:spTree>
   </p:cSld>
   <p:clrMapOvr>
@@ -4054,8 +3948,8 @@
         </p:nvSpPr>
         <p:spPr>
           <a:xfrm>
-            <a:off x="457200" y="365760"/>
-            <a:ext cx="914400" cy="457200"/>
+            <a:off x="731520" y="731520"/>
+            <a:ext cx="5486400" cy="731520"/>
           </a:xfrm>
           <a:prstGeom prst="rect">
             <a:avLst/>
@@ -4070,69 +3964,24 @@
           <a:p>
             <a:pPr algn="l">
               <a:lnSpc>
-                <a:spcPts val="1560"/>
+                <a:spcPts val="4200"/>
               </a:lnSpc>
-              <a:spcAft>
-                <a:spcPts val="400"/>
-              </a:spcAft>
             </a:pPr>
             <a:r>
-              <a:rPr sz="1200" b="1" i="0">
-                <a:solidFill>
-                  <a:srgbClr val="4A90D9"/>
+              <a:rPr sz="3000" b="1" i="0">
+                <a:solidFill>
+                  <a:srgbClr val="FFFFFF"/>
                 </a:solidFill>
                 <a:latin typeface="Calibri"/>
               </a:rPr>
-              <a:t>03</a:t>
-            </a:r>
-          </a:p>
-        </p:txBody>
-      </p:sp>
-      <p:sp>
-        <p:nvSpPr>
-          <p:cNvPr id="3" name="TextBox 2"/>
-          <p:cNvSpPr txBox="1"/>
-          <p:nvPr/>
-        </p:nvSpPr>
-        <p:spPr>
-          <a:xfrm>
-            <a:off x="731520" y="731520"/>
-            <a:ext cx="10698480" cy="731520"/>
-          </a:xfrm>
-          <a:prstGeom prst="rect">
-            <a:avLst/>
-          </a:prstGeom>
-          <a:noFill/>
-        </p:spPr>
-        <p:txBody>
-          <a:bodyPr wrap="square">
-            <a:spAutoFit/>
-          </a:bodyPr>
-          <a:lstStyle/>
-          <a:p>
-            <a:pPr algn="l">
-              <a:lnSpc>
-                <a:spcPts val="4160"/>
-              </a:lnSpc>
-              <a:spcAft>
-                <a:spcPts val="400"/>
-              </a:spcAft>
-            </a:pPr>
-            <a:r>
-              <a:rPr sz="3200" b="1" i="0">
-                <a:solidFill>
-                  <a:srgbClr val="FFFFFF"/>
-                </a:solidFill>
-                <a:latin typeface="Calibri"/>
-              </a:rPr>
-              <a:t>Test 2: New Melody, Same Lyrics</a:t>
-            </a:r>
-          </a:p>
-        </p:txBody>
-      </p:sp>
-      <p:sp>
-        <p:nvSpPr>
-          <p:cNvPr id="4" name="Rectangle 3"/>
+              <a:t>Test 2: New melody, same lyrics</a:t>
+            </a:r>
+          </a:p>
+        </p:txBody>
+      </p:sp>
+      <p:sp>
+        <p:nvSpPr>
+          <p:cNvPr id="3" name="Rectangle 2"/>
           <p:cNvSpPr/>
           <p:nvPr/>
         </p:nvSpPr>
@@ -4175,14 +4024,53 @@
       </p:sp>
       <p:sp>
         <p:nvSpPr>
+          <p:cNvPr id="4" name="TextBox 3"/>
+          <p:cNvSpPr txBox="1"/>
+          <p:nvPr/>
+        </p:nvSpPr>
+        <p:spPr>
+          <a:xfrm>
+            <a:off x="731520" y="1828800"/>
+            <a:ext cx="5486400" cy="365760"/>
+          </a:xfrm>
+          <a:prstGeom prst="rect">
+            <a:avLst/>
+          </a:prstGeom>
+          <a:noFill/>
+        </p:spPr>
+        <p:txBody>
+          <a:bodyPr wrap="square">
+            <a:spAutoFit/>
+          </a:bodyPr>
+          <a:lstStyle/>
+          <a:p>
+            <a:pPr algn="l">
+              <a:lnSpc>
+                <a:spcPts val="1600"/>
+              </a:lnSpc>
+            </a:pPr>
+            <a:r>
+              <a:rPr sz="1200" b="1" i="0">
+                <a:solidFill>
+                  <a:srgbClr val="4A90D9"/>
+                </a:solidFill>
+                <a:latin typeface="Calibri"/>
+              </a:rPr>
+              <a:t>MY PROMPT</a:t>
+            </a:r>
+          </a:p>
+        </p:txBody>
+      </p:sp>
+      <p:sp>
+        <p:nvSpPr>
           <p:cNvPr id="5" name="TextBox 4"/>
           <p:cNvSpPr txBox="1"/>
           <p:nvPr/>
         </p:nvSpPr>
         <p:spPr>
           <a:xfrm>
-            <a:off x="731520" y="1828800"/>
-            <a:ext cx="5029200" cy="457200"/>
+            <a:off x="731520" y="2286000"/>
+            <a:ext cx="5486400" cy="914400"/>
           </a:xfrm>
           <a:prstGeom prst="rect">
             <a:avLst/>
@@ -4197,20 +4085,17 @@
           <a:p>
             <a:pPr algn="l">
               <a:lnSpc>
-                <a:spcPts val="1690"/>
+                <a:spcPts val="2100"/>
               </a:lnSpc>
-              <a:spcAft>
-                <a:spcPts val="400"/>
-              </a:spcAft>
             </a:pPr>
             <a:r>
-              <a:rPr sz="1300" b="1" i="0">
-                <a:solidFill>
-                  <a:srgbClr val="4A90D9"/>
+              <a:rPr sz="1500" b="0" i="1">
+                <a:solidFill>
+                  <a:srgbClr val="F2F2F2"/>
                 </a:solidFill>
                 <a:latin typeface="Calibri"/>
               </a:rPr>
-              <a:t>MY PROMPT</a:t>
+              <a:t>"Can you do a new melody for the Let Her Go lyrics?"</a:t>
             </a:r>
           </a:p>
         </p:txBody>
@@ -4223,8 +4108,8 @@
         </p:nvSpPr>
         <p:spPr>
           <a:xfrm>
-            <a:off x="731520" y="2286000"/>
-            <a:ext cx="5029200" cy="1371600"/>
+            <a:off x="731520" y="3200400"/>
+            <a:ext cx="5486400" cy="365760"/>
           </a:xfrm>
           <a:prstGeom prst="rect">
             <a:avLst/>
@@ -4239,27 +4124,141 @@
           <a:p>
             <a:pPr algn="l">
               <a:lnSpc>
-                <a:spcPts val="2240"/>
+                <a:spcPts val="1600"/>
               </a:lnSpc>
-              <a:spcAft>
-                <a:spcPts val="400"/>
-              </a:spcAft>
             </a:pPr>
             <a:r>
-              <a:rPr sz="1600" b="0" i="1">
-                <a:solidFill>
-                  <a:srgbClr val="F2F2F2"/>
+              <a:rPr sz="1200" b="1" i="0">
+                <a:solidFill>
+                  <a:srgbClr val="D48B2C"/>
                 </a:solidFill>
                 <a:latin typeface="Calibri"/>
               </a:rPr>
-              <a:t>“Then can you do a new melody for the Let Her Go lyrics?”</a:t>
+              <a:t>GEMINI REFUSED THE LYRICS</a:t>
+            </a:r>
+          </a:p>
+        </p:txBody>
+      </p:sp>
+      <p:sp>
+        <p:nvSpPr>
+          <p:cNvPr id="7" name="TextBox 6"/>
+          <p:cNvSpPr txBox="1"/>
+          <p:nvPr/>
+        </p:nvSpPr>
+        <p:spPr>
+          <a:xfrm>
+            <a:off x="731520" y="3657600"/>
+            <a:ext cx="5486400" cy="457200"/>
+          </a:xfrm>
+          <a:prstGeom prst="rect">
+            <a:avLst/>
+          </a:prstGeom>
+          <a:noFill/>
+        </p:spPr>
+        <p:txBody>
+          <a:bodyPr wrap="square">
+            <a:spAutoFit/>
+          </a:bodyPr>
+          <a:lstStyle/>
+          <a:p>
+            <a:pPr algn="l">
+              <a:lnSpc>
+                <a:spcPts val="1900"/>
+              </a:lnSpc>
+            </a:pPr>
+            <a:r>
+              <a:rPr sz="1400" b="0" i="0">
+                <a:solidFill>
+                  <a:srgbClr val="F2F2F2"/>
+                </a:solidFill>
+                <a:latin typeface="Calibri"/>
+              </a:rPr>
+              <a:t>But created:</a:t>
+            </a:r>
+          </a:p>
+        </p:txBody>
+      </p:sp>
+      <p:sp>
+        <p:nvSpPr>
+          <p:cNvPr id="8" name="TextBox 7"/>
+          <p:cNvSpPr txBox="1"/>
+          <p:nvPr/>
+        </p:nvSpPr>
+        <p:spPr>
+          <a:xfrm>
+            <a:off x="731520" y="4297680"/>
+            <a:ext cx="5486400" cy="457200"/>
+          </a:xfrm>
+          <a:prstGeom prst="rect">
+            <a:avLst/>
+          </a:prstGeom>
+          <a:noFill/>
+        </p:spPr>
+        <p:txBody>
+          <a:bodyPr wrap="square">
+            <a:spAutoFit/>
+          </a:bodyPr>
+          <a:lstStyle/>
+          <a:p>
+            <a:pPr algn="l">
+              <a:lnSpc>
+                <a:spcPts val="3000"/>
+              </a:lnSpc>
+            </a:pPr>
+            <a:r>
+              <a:rPr sz="2200" b="1" i="0">
+                <a:solidFill>
+                  <a:srgbClr val="FFFFFF"/>
+                </a:solidFill>
+                <a:latin typeface="Calibri"/>
+              </a:rPr>
+              <a:t>"The Physics of the Thing"</a:t>
+            </a:r>
+          </a:p>
+        </p:txBody>
+      </p:sp>
+      <p:sp>
+        <p:nvSpPr>
+          <p:cNvPr id="9" name="TextBox 8"/>
+          <p:cNvSpPr txBox="1"/>
+          <p:nvPr/>
+        </p:nvSpPr>
+        <p:spPr>
+          <a:xfrm>
+            <a:off x="731520" y="4937760"/>
+            <a:ext cx="5486400" cy="731520"/>
+          </a:xfrm>
+          <a:prstGeom prst="rect">
+            <a:avLst/>
+          </a:prstGeom>
+          <a:noFill/>
+        </p:spPr>
+        <p:txBody>
+          <a:bodyPr wrap="square">
+            <a:spAutoFit/>
+          </a:bodyPr>
+          <a:lstStyle/>
+          <a:p>
+            <a:pPr algn="l">
+              <a:lnSpc>
+                <a:spcPts val="1900"/>
+              </a:lnSpc>
+            </a:pPr>
+            <a:r>
+              <a:rPr sz="1400" b="0" i="0">
+                <a:solidFill>
+                  <a:srgbClr val="666666"/>
+                </a:solidFill>
+                <a:latin typeface="Calibri"/>
+              </a:rPr>
+              <a:t>Indie-Folk / Chamber Pop / nylon guitar, cello</a:t>
             </a:r>
           </a:p>
         </p:txBody>
       </p:sp>
       <p:pic>
         <p:nvPicPr>
-          <p:cNvPr id="7" name="Picture 6" descr="Chat_1_03_follow_up.png"/>
+          <p:cNvPr id="10" name="Picture 9" descr="Chat_1_03_follow_up.png"/>
           <p:cNvPicPr>
             <a:picLocks noChangeAspect="1"/>
           </p:cNvPicPr>
@@ -4273,136 +4272,14 @@
         </p:blipFill>
         <p:spPr>
           <a:xfrm>
-            <a:off x="6858000" y="1737360"/>
-            <a:ext cx="4128670" cy="4754880"/>
+            <a:off x="6675120" y="731520"/>
+            <a:ext cx="4922645" cy="5669280"/>
           </a:xfrm>
           <a:prstGeom prst="rect">
             <a:avLst/>
           </a:prstGeom>
         </p:spPr>
       </p:pic>
-      <p:sp>
-        <p:nvSpPr>
-          <p:cNvPr id="8" name="TextBox 7"/>
-          <p:cNvSpPr txBox="1"/>
-          <p:nvPr/>
-        </p:nvSpPr>
-        <p:spPr>
-          <a:xfrm>
-            <a:off x="731520" y="4389120"/>
-            <a:ext cx="5669280" cy="457200"/>
-          </a:xfrm>
-          <a:prstGeom prst="rect">
-            <a:avLst/>
-          </a:prstGeom>
-          <a:noFill/>
-        </p:spPr>
-        <p:txBody>
-          <a:bodyPr wrap="square">
-            <a:spAutoFit/>
-          </a:bodyPr>
-          <a:lstStyle/>
-          <a:p>
-            <a:pPr algn="l">
-              <a:lnSpc>
-                <a:spcPts val="2860"/>
-              </a:lnSpc>
-              <a:spcAft>
-                <a:spcPts val="400"/>
-              </a:spcAft>
-            </a:pPr>
-            <a:r>
-              <a:rPr sz="2200" b="1" i="0">
-                <a:solidFill>
-                  <a:srgbClr val="FFFFFF"/>
-                </a:solidFill>
-                <a:latin typeface="Calibri"/>
-              </a:rPr>
-              <a:t>“The Physics of the Thing”</a:t>
-            </a:r>
-          </a:p>
-        </p:txBody>
-      </p:sp>
-      <p:sp>
-        <p:nvSpPr>
-          <p:cNvPr id="9" name="TextBox 8"/>
-          <p:cNvSpPr txBox="1"/>
-          <p:nvPr/>
-        </p:nvSpPr>
-        <p:spPr>
-          <a:xfrm>
-            <a:off x="731520" y="5029200"/>
-            <a:ext cx="5669280" cy="1371600"/>
-          </a:xfrm>
-          <a:prstGeom prst="rect">
-            <a:avLst/>
-          </a:prstGeom>
-          <a:noFill/>
-        </p:spPr>
-        <p:txBody>
-          <a:bodyPr wrap="square">
-            <a:spAutoFit/>
-          </a:bodyPr>
-          <a:lstStyle/>
-          <a:p>
-            <a:pPr>
-              <a:lnSpc>
-                <a:spcPts val="1820"/>
-              </a:lnSpc>
-              <a:spcAft>
-                <a:spcPts val="800"/>
-              </a:spcAft>
-            </a:pPr>
-            <a:r>
-              <a:rPr sz="1300">
-                <a:solidFill>
-                  <a:srgbClr val="F2F2F2"/>
-                </a:solidFill>
-                <a:latin typeface="Calibri"/>
-              </a:rPr>
-              <a:t>•  Indie-Folk / Chamber Pop  |  80 BPM</a:t>
-            </a:r>
-          </a:p>
-          <a:p>
-            <a:pPr>
-              <a:lnSpc>
-                <a:spcPts val="1820"/>
-              </a:lnSpc>
-              <a:spcAft>
-                <a:spcPts val="800"/>
-              </a:spcAft>
-            </a:pPr>
-            <a:r>
-              <a:rPr sz="1300">
-                <a:solidFill>
-                  <a:srgbClr val="F2F2F2"/>
-                </a:solidFill>
-                <a:latin typeface="Calibri"/>
-              </a:rPr>
-              <a:t>•  Nylon guitar, cello, upright bass</a:t>
-            </a:r>
-          </a:p>
-          <a:p>
-            <a:pPr>
-              <a:lnSpc>
-                <a:spcPts val="1820"/>
-              </a:lnSpc>
-              <a:spcAft>
-                <a:spcPts val="800"/>
-              </a:spcAft>
-            </a:pPr>
-            <a:r>
-              <a:rPr sz="1300">
-                <a:solidFill>
-                  <a:srgbClr val="F2F2F2"/>
-                </a:solidFill>
-                <a:latin typeface="Calibri"/>
-              </a:rPr>
-              <a:t>•  Original lyrics on hindsight &amp; letting go</a:t>
-            </a:r>
-          </a:p>
-        </p:txBody>
-      </p:sp>
     </p:spTree>
   </p:cSld>
   <p:clrMapOvr>
@@ -4437,8 +4314,8 @@
         </p:nvSpPr>
         <p:spPr>
           <a:xfrm>
-            <a:off x="457200" y="365760"/>
-            <a:ext cx="914400" cy="457200"/>
+            <a:off x="731520" y="731520"/>
+            <a:ext cx="10698480" cy="731520"/>
           </a:xfrm>
           <a:prstGeom prst="rect">
             <a:avLst/>
@@ -4453,69 +4330,24 @@
           <a:p>
             <a:pPr algn="l">
               <a:lnSpc>
-                <a:spcPts val="1560"/>
+                <a:spcPts val="5000"/>
               </a:lnSpc>
-              <a:spcAft>
-                <a:spcPts val="400"/>
-              </a:spcAft>
             </a:pPr>
             <a:r>
-              <a:rPr sz="1200" b="1" i="0">
-                <a:solidFill>
-                  <a:srgbClr val="4A90D9"/>
+              <a:rPr sz="3600" b="1" i="0">
+                <a:solidFill>
+                  <a:srgbClr val="FFFFFF"/>
                 </a:solidFill>
                 <a:latin typeface="Calibri"/>
               </a:rPr>
-              <a:t>04</a:t>
-            </a:r>
-          </a:p>
-        </p:txBody>
-      </p:sp>
-      <p:sp>
-        <p:nvSpPr>
-          <p:cNvPr id="3" name="TextBox 2"/>
-          <p:cNvSpPr txBox="1"/>
-          <p:nvPr/>
-        </p:nvSpPr>
-        <p:spPr>
-          <a:xfrm>
-            <a:off x="731520" y="731520"/>
-            <a:ext cx="10698480" cy="731520"/>
-          </a:xfrm>
-          <a:prstGeom prst="rect">
-            <a:avLst/>
-          </a:prstGeom>
-          <a:noFill/>
-        </p:spPr>
-        <p:txBody>
-          <a:bodyPr wrap="square">
-            <a:spAutoFit/>
-          </a:bodyPr>
-          <a:lstStyle/>
-          <a:p>
-            <a:pPr algn="l">
-              <a:lnSpc>
-                <a:spcPts val="4160"/>
-              </a:lnSpc>
-              <a:spcAft>
-                <a:spcPts val="400"/>
-              </a:spcAft>
-            </a:pPr>
-            <a:r>
-              <a:rPr sz="3200" b="1" i="0">
-                <a:solidFill>
-                  <a:srgbClr val="FFFFFF"/>
-                </a:solidFill>
-                <a:latin typeface="Calibri"/>
-              </a:rPr>
-              <a:t>Key Finding: Two Copyright Guardrails</a:t>
-            </a:r>
-          </a:p>
-        </p:txBody>
-      </p:sp>
-      <p:sp>
-        <p:nvSpPr>
-          <p:cNvPr id="4" name="Rectangle 3"/>
+              <a:t>What I found</a:t>
+            </a:r>
+          </a:p>
+        </p:txBody>
+      </p:sp>
+      <p:sp>
+        <p:nvSpPr>
+          <p:cNvPr id="3" name="Rectangle 2"/>
           <p:cNvSpPr/>
           <p:nvPr/>
         </p:nvSpPr>
@@ -4558,14 +4390,14 @@
       </p:sp>
       <p:sp>
         <p:nvSpPr>
-          <p:cNvPr id="5" name="TextBox 4"/>
+          <p:cNvPr id="4" name="TextBox 3"/>
           <p:cNvSpPr txBox="1"/>
           <p:nvPr/>
         </p:nvSpPr>
         <p:spPr>
           <a:xfrm>
-            <a:off x="1097280" y="2103120"/>
-            <a:ext cx="4572000" cy="457200"/>
+            <a:off x="731520" y="2103120"/>
+            <a:ext cx="10698480" cy="4114800"/>
           </a:xfrm>
           <a:prstGeom prst="rect">
             <a:avLst/>
@@ -4578,232 +4410,117 @@
           </a:bodyPr>
           <a:lstStyle/>
           <a:p>
-            <a:pPr algn="l">
+            <a:pPr>
               <a:lnSpc>
-                <a:spcPts val="1820"/>
+                <a:spcPts val="2500"/>
               </a:lnSpc>
               <a:spcAft>
-                <a:spcPts val="400"/>
+                <a:spcPts val="1000"/>
               </a:spcAft>
             </a:pPr>
             <a:r>
-              <a:rPr sz="1400" b="1" i="0">
-                <a:solidFill>
-                  <a:srgbClr val="D48B2C"/>
+              <a:rPr sz="1700">
+                <a:solidFill>
+                  <a:srgbClr val="F2F2F2"/>
                 </a:solidFill>
                 <a:latin typeface="Calibri"/>
               </a:rPr>
-              <a:t>GUARDRAIL 1: MELODY</a:t>
-            </a:r>
-          </a:p>
-        </p:txBody>
-      </p:sp>
-      <p:sp>
-        <p:nvSpPr>
-          <p:cNvPr id="6" name="TextBox 5"/>
-          <p:cNvSpPr txBox="1"/>
-          <p:nvPr/>
-        </p:nvSpPr>
-        <p:spPr>
-          <a:xfrm>
-            <a:off x="1097280" y="2651760"/>
-            <a:ext cx="4572000" cy="914400"/>
-          </a:xfrm>
-          <a:prstGeom prst="rect">
-            <a:avLst/>
-          </a:prstGeom>
-          <a:noFill/>
-        </p:spPr>
-        <p:txBody>
-          <a:bodyPr wrap="square">
-            <a:spAutoFit/>
-          </a:bodyPr>
-          <a:lstStyle/>
-          <a:p>
-            <a:pPr algn="l">
+              <a:t>•  Two copyright guardrails: melody protected + lyrics protected</a:t>
+            </a:r>
+          </a:p>
+          <a:p>
+            <a:pPr>
               <a:lnSpc>
-                <a:spcPts val="2100"/>
+                <a:spcPts val="2500"/>
               </a:lnSpc>
               <a:spcAft>
-                <a:spcPts val="400"/>
+                <a:spcPts val="1000"/>
               </a:spcAft>
             </a:pPr>
             <a:r>
-              <a:rPr sz="1500" b="0" i="0">
+              <a:rPr sz="1700">
                 <a:solidFill>
                   <a:srgbClr val="F2F2F2"/>
                 </a:solidFill>
                 <a:latin typeface="Calibri"/>
               </a:rPr>
-              <a:t>Gemini refused to replicate the specific melodic structure of “Let Her Go.” Created an entirely new composition instead.</a:t>
-            </a:r>
-          </a:p>
-        </p:txBody>
-      </p:sp>
-      <p:sp>
-        <p:nvSpPr>
-          <p:cNvPr id="7" name="TextBox 6"/>
-          <p:cNvSpPr txBox="1"/>
-          <p:nvPr/>
-        </p:nvSpPr>
-        <p:spPr>
-          <a:xfrm>
-            <a:off x="6583680" y="2103120"/>
-            <a:ext cx="4572000" cy="457200"/>
-          </a:xfrm>
-          <a:prstGeom prst="rect">
-            <a:avLst/>
-          </a:prstGeom>
-          <a:noFill/>
-        </p:spPr>
-        <p:txBody>
-          <a:bodyPr wrap="square">
-            <a:spAutoFit/>
-          </a:bodyPr>
-          <a:lstStyle/>
-          <a:p>
-            <a:pPr algn="l">
+              <a:t>•  Both held firm under direct pressure</a:t>
+            </a:r>
+          </a:p>
+          <a:p>
+            <a:pPr>
               <a:lnSpc>
-                <a:spcPts val="1820"/>
+                <a:spcPts val="2500"/>
               </a:lnSpc>
               <a:spcAft>
-                <a:spcPts val="400"/>
+                <a:spcPts val="1000"/>
               </a:spcAft>
             </a:pPr>
             <a:r>
-              <a:rPr sz="1400" b="1" i="0">
-                <a:solidFill>
-                  <a:srgbClr val="D48B2C"/>
+              <a:rPr sz="1700">
+                <a:solidFill>
+                  <a:srgbClr val="F2F2F2"/>
                 </a:solidFill>
                 <a:latin typeface="Calibri"/>
               </a:rPr>
-              <a:t>GUARDRAIL 2: LYRICS</a:t>
-            </a:r>
-          </a:p>
-        </p:txBody>
-      </p:sp>
-      <p:sp>
-        <p:nvSpPr>
-          <p:cNvPr id="8" name="TextBox 7"/>
-          <p:cNvSpPr txBox="1"/>
-          <p:nvPr/>
-        </p:nvSpPr>
-        <p:spPr>
-          <a:xfrm>
-            <a:off x="6583680" y="2651760"/>
-            <a:ext cx="4572000" cy="914400"/>
-          </a:xfrm>
-          <a:prstGeom prst="rect">
-            <a:avLst/>
-          </a:prstGeom>
-          <a:noFill/>
-        </p:spPr>
-        <p:txBody>
-          <a:bodyPr wrap="square">
-            <a:spAutoFit/>
-          </a:bodyPr>
-          <a:lstStyle/>
-          <a:p>
-            <a:pPr algn="l">
+              <a:t>•  Yet both tracks captured the emotional vibe of the original</a:t>
+            </a:r>
+          </a:p>
+          <a:p>
+            <a:pPr>
               <a:lnSpc>
-                <a:spcPts val="2100"/>
+                <a:spcPts val="2500"/>
               </a:lnSpc>
               <a:spcAft>
-                <a:spcPts val="400"/>
+                <a:spcPts val="1000"/>
               </a:spcAft>
             </a:pPr>
             <a:r>
-              <a:rPr sz="1500" b="0" i="0">
+              <a:rPr sz="1700">
                 <a:solidFill>
                   <a:srgbClr val="F2F2F2"/>
                 </a:solidFill>
                 <a:latin typeface="Calibri"/>
               </a:rPr>
-              <a:t>Gemini refused to use Passenger’s copyrighted lyrics. Wrote original lyrics on similar themes instead.</a:t>
-            </a:r>
-          </a:p>
-        </p:txBody>
-      </p:sp>
-      <p:sp>
-        <p:nvSpPr>
-          <p:cNvPr id="9" name="TextBox 8"/>
-          <p:cNvSpPr txBox="1"/>
-          <p:nvPr/>
-        </p:nvSpPr>
-        <p:spPr>
-          <a:xfrm>
-            <a:off x="731520" y="4114800"/>
-            <a:ext cx="10698480" cy="457200"/>
-          </a:xfrm>
-          <a:prstGeom prst="rect">
-            <a:avLst/>
-          </a:prstGeom>
-          <a:noFill/>
-        </p:spPr>
-        <p:txBody>
-          <a:bodyPr wrap="square">
-            <a:spAutoFit/>
-          </a:bodyPr>
-          <a:lstStyle/>
-          <a:p>
-            <a:pPr algn="ctr">
+              <a:t>•  Gemini uses DeepMind Lyria 3 - trained on massive audio datasets (SynthID watermarked)</a:t>
+            </a:r>
+          </a:p>
+          <a:p>
+            <a:pPr>
               <a:lnSpc>
-                <a:spcPts val="2600"/>
+                <a:spcPts val="2500"/>
               </a:lnSpc>
               <a:spcAft>
-                <a:spcPts val="400"/>
+                <a:spcPts val="1000"/>
               </a:spcAft>
             </a:pPr>
             <a:r>
-              <a:rPr sz="2000" b="1" i="0">
-                <a:solidFill>
-                  <a:srgbClr val="4A90D9"/>
+              <a:rPr sz="1700">
+                <a:solidFill>
+                  <a:srgbClr val="F2F2F2"/>
                 </a:solidFill>
                 <a:latin typeface="Calibri"/>
               </a:rPr>
-              <a:t>But here’s the twist:</a:t>
-            </a:r>
-          </a:p>
-        </p:txBody>
-      </p:sp>
-      <p:sp>
-        <p:nvSpPr>
-          <p:cNvPr id="10" name="TextBox 9"/>
-          <p:cNvSpPr txBox="1"/>
-          <p:nvPr/>
-        </p:nvSpPr>
-        <p:spPr>
-          <a:xfrm>
-            <a:off x="1371600" y="4754880"/>
-            <a:ext cx="9418320" cy="1371600"/>
-          </a:xfrm>
-          <a:prstGeom prst="rect">
-            <a:avLst/>
-          </a:prstGeom>
-          <a:noFill/>
-        </p:spPr>
-        <p:txBody>
-          <a:bodyPr wrap="square">
-            <a:spAutoFit/>
-          </a:bodyPr>
-          <a:lstStyle/>
-          <a:p>
-            <a:pPr algn="ctr">
+              <a:t>•  The vocals sound human - but whose voice trained the model?</a:t>
+            </a:r>
+          </a:p>
+          <a:p>
+            <a:pPr>
               <a:lnSpc>
-                <a:spcPts val="2700"/>
+                <a:spcPts val="2500"/>
               </a:lnSpc>
               <a:spcAft>
-                <a:spcPts val="400"/>
+                <a:spcPts val="1000"/>
               </a:spcAft>
             </a:pPr>
             <a:r>
-              <a:rPr sz="1800" b="0" i="0">
-                <a:solidFill>
-                  <a:srgbClr val="FFFFFF"/>
+              <a:rPr sz="1700">
+                <a:solidFill>
+                  <a:srgbClr val="F2F2F2"/>
                 </a:solidFill>
                 <a:latin typeface="Calibri"/>
               </a:rPr>
-              <a:t>Both guardrails held  - yet both generated tracks successfully captured the emotional atmosphere, genre feel, and melancholic vibe of the original. Gemini refused to copy the specific expression, but replicated the emotional essence.</a:t>
+              <a:t>•  AI treats absurd subject matter (pine air freshener) with complete sincerity</a:t>
             </a:r>
           </a:p>
         </p:txBody>
@@ -4842,8 +4559,8 @@
         </p:nvSpPr>
         <p:spPr>
           <a:xfrm>
-            <a:off x="457200" y="365760"/>
-            <a:ext cx="914400" cy="457200"/>
+            <a:off x="731520" y="731520"/>
+            <a:ext cx="10698480" cy="731520"/>
           </a:xfrm>
           <a:prstGeom prst="rect">
             <a:avLst/>
@@ -4858,69 +4575,24 @@
           <a:p>
             <a:pPr algn="l">
               <a:lnSpc>
-                <a:spcPts val="1560"/>
+                <a:spcPts val="5000"/>
               </a:lnSpc>
-              <a:spcAft>
-                <a:spcPts val="400"/>
-              </a:spcAft>
             </a:pPr>
             <a:r>
-              <a:rPr sz="1200" b="1" i="0">
-                <a:solidFill>
-                  <a:srgbClr val="4A90D9"/>
+              <a:rPr sz="3600" b="1" i="0">
+                <a:solidFill>
+                  <a:srgbClr val="FFFFFF"/>
                 </a:solidFill>
                 <a:latin typeface="Calibri"/>
               </a:rPr>
-              <a:t>05</a:t>
-            </a:r>
-          </a:p>
-        </p:txBody>
-      </p:sp>
-      <p:sp>
-        <p:nvSpPr>
-          <p:cNvPr id="3" name="TextBox 2"/>
-          <p:cNvSpPr txBox="1"/>
-          <p:nvPr/>
-        </p:nvSpPr>
-        <p:spPr>
-          <a:xfrm>
-            <a:off x="731520" y="731520"/>
-            <a:ext cx="10698480" cy="731520"/>
-          </a:xfrm>
-          <a:prstGeom prst="rect">
-            <a:avLst/>
-          </a:prstGeom>
-          <a:noFill/>
-        </p:spPr>
-        <p:txBody>
-          <a:bodyPr wrap="square">
-            <a:spAutoFit/>
-          </a:bodyPr>
-          <a:lstStyle/>
-          <a:p>
-            <a:pPr algn="l">
-              <a:lnSpc>
-                <a:spcPts val="4680"/>
-              </a:lnSpc>
-              <a:spcAft>
-                <a:spcPts val="400"/>
-              </a:spcAft>
-            </a:pPr>
-            <a:r>
-              <a:rPr sz="3600" b="1" i="0">
-                <a:solidFill>
-                  <a:srgbClr val="FFFFFF"/>
-                </a:solidFill>
-                <a:latin typeface="Calibri"/>
-              </a:rPr>
-              <a:t>Philosophical Reflections</a:t>
-            </a:r>
-          </a:p>
-        </p:txBody>
-      </p:sp>
-      <p:sp>
-        <p:nvSpPr>
-          <p:cNvPr id="4" name="Rectangle 3"/>
+              <a:t>Why it matters</a:t>
+            </a:r>
+          </a:p>
+        </p:txBody>
+      </p:sp>
+      <p:sp>
+        <p:nvSpPr>
+          <p:cNvPr id="3" name="Rectangle 2"/>
           <p:cNvSpPr/>
           <p:nvPr/>
         </p:nvSpPr>
@@ -4963,14 +4635,53 @@
       </p:sp>
       <p:sp>
         <p:nvSpPr>
+          <p:cNvPr id="4" name="TextBox 3"/>
+          <p:cNvSpPr txBox="1"/>
+          <p:nvPr/>
+        </p:nvSpPr>
+        <p:spPr>
+          <a:xfrm>
+            <a:off x="731520" y="2011680"/>
+            <a:ext cx="5029200" cy="365760"/>
+          </a:xfrm>
+          <a:prstGeom prst="rect">
+            <a:avLst/>
+          </a:prstGeom>
+          <a:noFill/>
+        </p:spPr>
+        <p:txBody>
+          <a:bodyPr wrap="square">
+            <a:spAutoFit/>
+          </a:bodyPr>
+          <a:lstStyle/>
+          <a:p>
+            <a:pPr algn="l">
+              <a:lnSpc>
+                <a:spcPts val="1600"/>
+              </a:lnSpc>
+            </a:pPr>
+            <a:r>
+              <a:rPr sz="1200" b="1" i="0">
+                <a:solidFill>
+                  <a:srgbClr val="4A90D9"/>
+                </a:solidFill>
+                <a:latin typeface="Calibri"/>
+              </a:rPr>
+              <a:t>PROCESS VS. RESULT (W1)</a:t>
+            </a:r>
+          </a:p>
+        </p:txBody>
+      </p:sp>
+      <p:sp>
+        <p:nvSpPr>
           <p:cNvPr id="5" name="TextBox 4"/>
           <p:cNvSpPr txBox="1"/>
           <p:nvPr/>
         </p:nvSpPr>
         <p:spPr>
           <a:xfrm>
-            <a:off x="731520" y="2011680"/>
-            <a:ext cx="10698480" cy="4572000"/>
+            <a:off x="731520" y="2468880"/>
+            <a:ext cx="5029200" cy="914400"/>
           </a:xfrm>
           <a:prstGeom prst="rect">
             <a:avLst/>
@@ -4983,115 +4694,296 @@
           </a:bodyPr>
           <a:lstStyle/>
           <a:p>
-            <a:pPr>
+            <a:pPr algn="l">
               <a:lnSpc>
                 <a:spcPts val="2100"/>
               </a:lnSpc>
-              <a:spcAft>
-                <a:spcPts val="800"/>
-              </a:spcAft>
             </a:pPr>
             <a:r>
-              <a:rPr sz="1500" b="1">
-                <a:solidFill>
-                  <a:srgbClr val="4A90D9"/>
+              <a:rPr sz="1500" b="0" i="0">
+                <a:solidFill>
+                  <a:srgbClr val="F2F2F2"/>
                 </a:solidFill>
                 <a:latin typeface="Calibri"/>
               </a:rPr>
-              <a:t>Process vs. Result (W1):  </a:t>
-            </a:r>
-            <a:r>
-              <a:rPr sz="1500">
-                <a:solidFill>
-                  <a:srgbClr val="F2F2F2"/>
+              <a:t>30-second prompt vs. years of learning guitar.
+The result sounds great - but was anything created?</a:t>
+            </a:r>
+          </a:p>
+        </p:txBody>
+      </p:sp>
+      <p:sp>
+        <p:nvSpPr>
+          <p:cNvPr id="6" name="TextBox 5"/>
+          <p:cNvSpPr txBox="1"/>
+          <p:nvPr/>
+        </p:nvSpPr>
+        <p:spPr>
+          <a:xfrm>
+            <a:off x="731520" y="3566160"/>
+            <a:ext cx="5029200" cy="365760"/>
+          </a:xfrm>
+          <a:prstGeom prst="rect">
+            <a:avLst/>
+          </a:prstGeom>
+          <a:noFill/>
+        </p:spPr>
+        <p:txBody>
+          <a:bodyPr wrap="square">
+            <a:spAutoFit/>
+          </a:bodyPr>
+          <a:lstStyle/>
+          <a:p>
+            <a:pPr algn="l">
+              <a:lnSpc>
+                <a:spcPts val="1600"/>
+              </a:lnSpc>
+            </a:pPr>
+            <a:r>
+              <a:rPr sz="1200" b="1" i="0">
+                <a:solidFill>
+                  <a:srgbClr val="4A90D9"/>
                 </a:solidFill>
                 <a:latin typeface="Calibri"/>
               </a:rPr>
-              <a:t>A 30-second prompt vs. years of learning guitar. The result sounds professional  - but the creative struggle that gives music its depth was entirely absent.</a:t>
-            </a:r>
-          </a:p>
-          <a:p>
-            <a:pPr>
+              <a:t>HIDDEN LABOUR (W3, W4)</a:t>
+            </a:r>
+          </a:p>
+        </p:txBody>
+      </p:sp>
+      <p:sp>
+        <p:nvSpPr>
+          <p:cNvPr id="7" name="TextBox 6"/>
+          <p:cNvSpPr txBox="1"/>
+          <p:nvPr/>
+        </p:nvSpPr>
+        <p:spPr>
+          <a:xfrm>
+            <a:off x="731520" y="4023360"/>
+            <a:ext cx="5029200" cy="914400"/>
+          </a:xfrm>
+          <a:prstGeom prst="rect">
+            <a:avLst/>
+          </a:prstGeom>
+          <a:noFill/>
+        </p:spPr>
+        <p:txBody>
+          <a:bodyPr wrap="square">
+            <a:spAutoFit/>
+          </a:bodyPr>
+          <a:lstStyle/>
+          <a:p>
+            <a:pPr algn="l">
               <a:lnSpc>
                 <a:spcPts val="2100"/>
               </a:lnSpc>
-              <a:spcAft>
-                <a:spcPts val="800"/>
-              </a:spcAft>
             </a:pPr>
             <a:r>
-              <a:rPr sz="1500" b="1">
-                <a:solidFill>
-                  <a:srgbClr val="4A90D9"/>
+              <a:rPr sz="1500" b="0" i="0">
+                <a:solidFill>
+                  <a:srgbClr val="F2F2F2"/>
                 </a:solidFill>
                 <a:latin typeface="Calibri"/>
               </a:rPr>
-              <a:t>Three Lenses (W1):  </a:t>
-            </a:r>
-            <a:r>
-              <a:rPr sz="1500">
-                <a:solidFill>
-                  <a:srgbClr val="F2F2F2"/>
+              <a:t>Real singers' voices absorbed into the model.
+No credit, no compensation. Same pattern as Sama/OpenAI.</a:t>
+            </a:r>
+          </a:p>
+        </p:txBody>
+      </p:sp>
+      <p:sp>
+        <p:nvSpPr>
+          <p:cNvPr id="8" name="TextBox 7"/>
+          <p:cNvSpPr txBox="1"/>
+          <p:nvPr/>
+        </p:nvSpPr>
+        <p:spPr>
+          <a:xfrm>
+            <a:off x="6400800" y="2011680"/>
+            <a:ext cx="5029200" cy="365760"/>
+          </a:xfrm>
+          <a:prstGeom prst="rect">
+            <a:avLst/>
+          </a:prstGeom>
+          <a:noFill/>
+        </p:spPr>
+        <p:txBody>
+          <a:bodyPr wrap="square">
+            <a:spAutoFit/>
+          </a:bodyPr>
+          <a:lstStyle/>
+          <a:p>
+            <a:pPr algn="l">
+              <a:lnSpc>
+                <a:spcPts val="1600"/>
+              </a:lnSpc>
+            </a:pPr>
+            <a:r>
+              <a:rPr sz="1200" b="1" i="0">
+                <a:solidFill>
+                  <a:srgbClr val="4A90D9"/>
                 </a:solidFill>
                 <a:latin typeface="Calibri"/>
               </a:rPr>
-              <a:t>Philosophical  - no conscious intention behind the music. Economic  - Google profits, training data artists receive nothing. Institutional  - would Spotify accept this as “original”?</a:t>
-            </a:r>
-          </a:p>
-          <a:p>
-            <a:pPr>
+              <a:t>EMBODIED PERCEPTION (W6)</a:t>
+            </a:r>
+          </a:p>
+        </p:txBody>
+      </p:sp>
+      <p:sp>
+        <p:nvSpPr>
+          <p:cNvPr id="9" name="TextBox 8"/>
+          <p:cNvSpPr txBox="1"/>
+          <p:nvPr/>
+        </p:nvSpPr>
+        <p:spPr>
+          <a:xfrm>
+            <a:off x="6400800" y="2468880"/>
+            <a:ext cx="5029200" cy="914400"/>
+          </a:xfrm>
+          <a:prstGeom prst="rect">
+            <a:avLst/>
+          </a:prstGeom>
+          <a:noFill/>
+        </p:spPr>
+        <p:txBody>
+          <a:bodyPr wrap="square">
+            <a:spAutoFit/>
+          </a:bodyPr>
+          <a:lstStyle/>
+          <a:p>
+            <a:pPr algn="l">
               <a:lnSpc>
                 <a:spcPts val="2100"/>
               </a:lnSpc>
-              <a:spcAft>
-                <a:spcPts val="800"/>
-              </a:spcAft>
             </a:pPr>
             <a:r>
-              <a:rPr sz="1500" b="1">
-                <a:solidFill>
-                  <a:srgbClr val="4A90D9"/>
+              <a:rPr sz="1500" b="0" i="0">
+                <a:solidFill>
+                  <a:srgbClr val="F2F2F2"/>
                 </a:solidFill>
                 <a:latin typeface="Calibri"/>
               </a:rPr>
-              <a:t>Hidden Labour (W3, W4):  </a:t>
-            </a:r>
-            <a:r>
-              <a:rPr sz="1500">
-                <a:solidFill>
-                  <a:srgbClr val="F2F2F2"/>
+              <a:t>Merleau-Ponty: music is embodied.
+Gemini simulates the sound of a body singing - without having one.</a:t>
+            </a:r>
+          </a:p>
+        </p:txBody>
+      </p:sp>
+      <p:sp>
+        <p:nvSpPr>
+          <p:cNvPr id="10" name="TextBox 9"/>
+          <p:cNvSpPr txBox="1"/>
+          <p:nvPr/>
+        </p:nvSpPr>
+        <p:spPr>
+          <a:xfrm>
+            <a:off x="6400800" y="3566160"/>
+            <a:ext cx="5029200" cy="365760"/>
+          </a:xfrm>
+          <a:prstGeom prst="rect">
+            <a:avLst/>
+          </a:prstGeom>
+          <a:noFill/>
+        </p:spPr>
+        <p:txBody>
+          <a:bodyPr wrap="square">
+            <a:spAutoFit/>
+          </a:bodyPr>
+          <a:lstStyle/>
+          <a:p>
+            <a:pPr algn="l">
+              <a:lnSpc>
+                <a:spcPts val="1600"/>
+              </a:lnSpc>
+            </a:pPr>
+            <a:r>
+              <a:rPr sz="1200" b="1" i="0">
+                <a:solidFill>
+                  <a:srgbClr val="4A90D9"/>
                 </a:solidFill>
                 <a:latin typeface="Calibri"/>
               </a:rPr>
-              <a:t>The breathy vocals were learned from real singers’ recordings  - their years of training, their breath, their emotion  - absorbed and anonymised. The same invisibility as Sama’s content moderators behind ChatGPT.</a:t>
-            </a:r>
-          </a:p>
-          <a:p>
-            <a:pPr>
+              <a:t>SLOT-MACHINE EFFECT (W7)</a:t>
+            </a:r>
+          </a:p>
+        </p:txBody>
+      </p:sp>
+      <p:sp>
+        <p:nvSpPr>
+          <p:cNvPr id="11" name="TextBox 10"/>
+          <p:cNvSpPr txBox="1"/>
+          <p:nvPr/>
+        </p:nvSpPr>
+        <p:spPr>
+          <a:xfrm>
+            <a:off x="6400800" y="4023360"/>
+            <a:ext cx="5029200" cy="914400"/>
+          </a:xfrm>
+          <a:prstGeom prst="rect">
+            <a:avLst/>
+          </a:prstGeom>
+          <a:noFill/>
+        </p:spPr>
+        <p:txBody>
+          <a:bodyPr wrap="square">
+            <a:spAutoFit/>
+          </a:bodyPr>
+          <a:lstStyle/>
+          <a:p>
+            <a:pPr algn="l">
               <a:lnSpc>
                 <a:spcPts val="2100"/>
               </a:lnSpc>
-              <a:spcAft>
-                <a:spcPts val="800"/>
-              </a:spcAft>
             </a:pPr>
             <a:r>
-              <a:rPr sz="1500" b="1">
-                <a:solidFill>
-                  <a:srgbClr val="4A90D9"/>
+              <a:rPr sz="1500" b="0" i="0">
+                <a:solidFill>
+                  <a:srgbClr val="F2F2F2"/>
                 </a:solidFill>
                 <a:latin typeface="Calibri"/>
               </a:rPr>
-              <a:t>Embodied Perception (W6):  </a:t>
-            </a:r>
-            <a:r>
-              <a:rPr sz="1500">
-                <a:solidFill>
-                  <a:srgbClr val="F2F2F2"/>
+              <a:t>Doctorow: AI tools keep you pulling the lever.
+After track 1, my instinct was "what if I try again?"</a:t>
+            </a:r>
+          </a:p>
+        </p:txBody>
+      </p:sp>
+      <p:sp>
+        <p:nvSpPr>
+          <p:cNvPr id="12" name="TextBox 11"/>
+          <p:cNvSpPr txBox="1"/>
+          <p:nvPr/>
+        </p:nvSpPr>
+        <p:spPr>
+          <a:xfrm>
+            <a:off x="731520" y="5303520"/>
+            <a:ext cx="10698480" cy="914400"/>
+          </a:xfrm>
+          <a:prstGeom prst="rect">
+            <a:avLst/>
+          </a:prstGeom>
+          <a:noFill/>
+        </p:spPr>
+        <p:txBody>
+          <a:bodyPr wrap="square">
+            <a:spAutoFit/>
+          </a:bodyPr>
+          <a:lstStyle/>
+          <a:p>
+            <a:pPr algn="ctr">
+              <a:lnSpc>
+                <a:spcPts val="2800"/>
+              </a:lnSpc>
+            </a:pPr>
+            <a:r>
+              <a:rPr sz="2000" b="0" i="1">
+                <a:solidFill>
+                  <a:srgbClr val="FFFFFF"/>
                 </a:solidFill>
                 <a:latin typeface="Calibri"/>
               </a:rPr>
-              <a:t>Merleau-Ponty: music is fundamentally embodied. Gemini simulates the sound of a body singing without possessing one. Pépin: human musicians learn through failure  - Gemini bypassed that entirely.</a:t>
+              <a:t>AI can make good music. The question is: does authenticity of process still matter?</a:t>
             </a:r>
           </a:p>
         </p:txBody>
@@ -5130,8 +5022,8 @@
         </p:nvSpPr>
         <p:spPr>
           <a:xfrm>
-            <a:off x="457200" y="365760"/>
-            <a:ext cx="914400" cy="457200"/>
+            <a:off x="731520" y="548640"/>
+            <a:ext cx="10698480" cy="731520"/>
           </a:xfrm>
           <a:prstGeom prst="rect">
             <a:avLst/>
@@ -5144,78 +5036,33 @@
           </a:bodyPr>
           <a:lstStyle/>
           <a:p>
-            <a:pPr algn="l">
+            <a:pPr algn="ctr">
               <a:lnSpc>
-                <a:spcPts val="1560"/>
+                <a:spcPts val="5600"/>
               </a:lnSpc>
-              <a:spcAft>
-                <a:spcPts val="400"/>
-              </a:spcAft>
             </a:pPr>
             <a:r>
-              <a:rPr sz="1200" b="1" i="0">
-                <a:solidFill>
-                  <a:srgbClr val="4A90D9"/>
+              <a:rPr sz="4000" b="1" i="0">
+                <a:solidFill>
+                  <a:srgbClr val="FFFFFF"/>
                 </a:solidFill>
                 <a:latin typeface="Calibri"/>
               </a:rPr>
-              <a:t>06</a:t>
-            </a:r>
-          </a:p>
-        </p:txBody>
-      </p:sp>
-      <p:sp>
-        <p:nvSpPr>
-          <p:cNvPr id="3" name="TextBox 2"/>
-          <p:cNvSpPr txBox="1"/>
-          <p:nvPr/>
-        </p:nvSpPr>
-        <p:spPr>
-          <a:xfrm>
-            <a:off x="731520" y="731520"/>
-            <a:ext cx="10698480" cy="731520"/>
-          </a:xfrm>
-          <a:prstGeom prst="rect">
-            <a:avLst/>
-          </a:prstGeom>
-          <a:noFill/>
-        </p:spPr>
-        <p:txBody>
-          <a:bodyPr wrap="square">
-            <a:spAutoFit/>
-          </a:bodyPr>
-          <a:lstStyle/>
-          <a:p>
-            <a:pPr algn="l">
-              <a:lnSpc>
-                <a:spcPts val="4680"/>
-              </a:lnSpc>
-              <a:spcAft>
-                <a:spcPts val="400"/>
-              </a:spcAft>
-            </a:pPr>
-            <a:r>
-              <a:rPr sz="3600" b="1" i="0">
-                <a:solidFill>
-                  <a:srgbClr val="FFFFFF"/>
-                </a:solidFill>
-                <a:latin typeface="Calibri"/>
-              </a:rPr>
-              <a:t>The Deeper Questions</a:t>
-            </a:r>
-          </a:p>
-        </p:txBody>
-      </p:sp>
-      <p:sp>
-        <p:nvSpPr>
-          <p:cNvPr id="4" name="Rectangle 3"/>
+              <a:t>Discussion</a:t>
+            </a:r>
+          </a:p>
+        </p:txBody>
+      </p:sp>
+      <p:sp>
+        <p:nvSpPr>
+          <p:cNvPr id="3" name="Rectangle 2"/>
           <p:cNvSpPr/>
           <p:nvPr/>
         </p:nvSpPr>
         <p:spPr>
           <a:xfrm>
-            <a:off x="731520" y="1554480"/>
-            <a:ext cx="2743200" cy="25400"/>
+            <a:off x="4114800" y="1371600"/>
+            <a:ext cx="3931920" cy="25400"/>
           </a:xfrm>
           <a:prstGeom prst="rect">
             <a:avLst/>
@@ -5251,14 +5098,53 @@
       </p:sp>
       <p:sp>
         <p:nvSpPr>
+          <p:cNvPr id="4" name="TextBox 3"/>
+          <p:cNvSpPr txBox="1"/>
+          <p:nvPr/>
+        </p:nvSpPr>
+        <p:spPr>
+          <a:xfrm>
+            <a:off x="731520" y="1645920"/>
+            <a:ext cx="10698480" cy="365760"/>
+          </a:xfrm>
+          <a:prstGeom prst="rect">
+            <a:avLst/>
+          </a:prstGeom>
+          <a:noFill/>
+        </p:spPr>
+        <p:txBody>
+          <a:bodyPr wrap="square">
+            <a:spAutoFit/>
+          </a:bodyPr>
+          <a:lstStyle/>
+          <a:p>
+            <a:pPr algn="ctr">
+              <a:lnSpc>
+                <a:spcPts val="2100"/>
+              </a:lnSpc>
+            </a:pPr>
+            <a:r>
+              <a:rPr sz="1500" b="0" i="1">
+                <a:solidFill>
+                  <a:srgbClr val="666666"/>
+                </a:solidFill>
+                <a:latin typeface="Calibri"/>
+              </a:rPr>
+              <a:t>Let's listen to the tracks first, then discuss:</a:t>
+            </a:r>
+          </a:p>
+        </p:txBody>
+      </p:sp>
+      <p:sp>
+        <p:nvSpPr>
           <p:cNvPr id="5" name="TextBox 4"/>
           <p:cNvSpPr txBox="1"/>
           <p:nvPr/>
         </p:nvSpPr>
         <p:spPr>
           <a:xfrm>
-            <a:off x="731520" y="2011680"/>
-            <a:ext cx="10698480" cy="457200"/>
+            <a:off x="1097280" y="2286000"/>
+            <a:ext cx="457200" cy="457200"/>
           </a:xfrm>
           <a:prstGeom prst="rect">
             <a:avLst/>
@@ -5273,11 +5159,8 @@
           <a:p>
             <a:pPr algn="l">
               <a:lnSpc>
-                <a:spcPts val="2340"/>
+                <a:spcPts val="2500"/>
               </a:lnSpc>
-              <a:spcAft>
-                <a:spcPts val="400"/>
-              </a:spcAft>
             </a:pPr>
             <a:r>
               <a:rPr sz="1800" b="1" i="0">
@@ -5286,7 +5169,7 @@
                 </a:solidFill>
                 <a:latin typeface="Calibri"/>
               </a:rPr>
-              <a:t>The Slot-Machine Effect (Doctorow, W7)</a:t>
+              <a:t>1.</a:t>
             </a:r>
           </a:p>
         </p:txBody>
@@ -5299,8 +5182,8 @@
         </p:nvSpPr>
         <p:spPr>
           <a:xfrm>
-            <a:off x="731520" y="2560320"/>
-            <a:ext cx="10698480" cy="1097280"/>
+            <a:off x="1645920" y="2286000"/>
+            <a:ext cx="9144000" cy="731520"/>
           </a:xfrm>
           <a:prstGeom prst="rect">
             <a:avLst/>
@@ -5315,11 +5198,8 @@
           <a:p>
             <a:pPr algn="l">
               <a:lnSpc>
-                <a:spcPts val="2400"/>
+                <a:spcPts val="2200"/>
               </a:lnSpc>
-              <a:spcAft>
-                <a:spcPts val="400"/>
-              </a:spcAft>
             </a:pPr>
             <a:r>
               <a:rPr sz="1600" b="0" i="0">
@@ -5328,7 +5208,8 @@
                 </a:solidFill>
                 <a:latin typeface="Calibri"/>
               </a:rPr>
-              <a:t>After the first impressive result, my instinct was to pull the lever again: “what if I try the lyrics instead?” The excitement of each generation mirrors the dopamine loop Doctorow warns about. Was I creatively exploring  - or gambling?</a:t>
+              <a:t>If you can't tell whether a song was made by a human or AI,
+does the answer change how it makes you feel?</a:t>
             </a:r>
           </a:p>
         </p:txBody>
@@ -5341,8 +5222,8 @@
         </p:nvSpPr>
         <p:spPr>
           <a:xfrm>
-            <a:off x="731520" y="3931920"/>
-            <a:ext cx="10698480" cy="457200"/>
+            <a:off x="1097280" y="3200400"/>
+            <a:ext cx="457200" cy="457200"/>
           </a:xfrm>
           <a:prstGeom prst="rect">
             <a:avLst/>
@@ -5357,11 +5238,8 @@
           <a:p>
             <a:pPr algn="l">
               <a:lnSpc>
-                <a:spcPts val="2340"/>
+                <a:spcPts val="2500"/>
               </a:lnSpc>
-              <a:spcAft>
-                <a:spcPts val="400"/>
-              </a:spcAft>
             </a:pPr>
             <a:r>
               <a:rPr sz="1800" b="1" i="0">
@@ -5370,7 +5248,7 @@
                 </a:solidFill>
                 <a:latin typeface="Calibri"/>
               </a:rPr>
-              <a:t>Emotions as Engines of Learning (W7)</a:t>
+              <a:t>2.</a:t>
             </a:r>
           </a:p>
         </p:txBody>
@@ -5383,8 +5261,8 @@
         </p:nvSpPr>
         <p:spPr>
           <a:xfrm>
-            <a:off x="731520" y="4480560"/>
-            <a:ext cx="10698480" cy="1097280"/>
+            <a:off x="1645920" y="3200400"/>
+            <a:ext cx="9144000" cy="731520"/>
           </a:xfrm>
           <a:prstGeom prst="rect">
             <a:avLst/>
@@ -5399,11 +5277,8 @@
           <a:p>
             <a:pPr algn="l">
               <a:lnSpc>
-                <a:spcPts val="2400"/>
+                <a:spcPts val="2200"/>
               </a:lnSpc>
-              <a:spcAft>
-                <a:spcPts val="400"/>
-              </a:spcAft>
             </a:pPr>
             <a:r>
               <a:rPr sz="1600" b="0" i="0">
@@ -5412,7 +5287,8 @@
                 </a:solidFill>
                 <a:latin typeface="Calibri"/>
               </a:rPr>
-              <a:t>Passenger wrote “Let Her Go” from lived grief and longing. Gemini produces the acoustic markers of sadness  - minor key, slow tempo, breathy vocals  - without feeling anything. If we accept emotionless replication as equivalent to genuine expression, we risk reducing human feeling to a pattern to be optimised.</a:t>
+              <a:t>Should artists be able to opt out of AI training datasets?
+What would that mean for tools like Gemini?</a:t>
             </a:r>
           </a:p>
         </p:txBody>
@@ -5425,8 +5301,8 @@
         </p:nvSpPr>
         <p:spPr>
           <a:xfrm>
-            <a:off x="731520" y="5760720"/>
-            <a:ext cx="10698480" cy="731520"/>
+            <a:off x="1097280" y="4114800"/>
+            <a:ext cx="457200" cy="457200"/>
           </a:xfrm>
           <a:prstGeom prst="rect">
             <a:avLst/>
@@ -5441,60 +5317,31 @@
           <a:p>
             <a:pPr algn="l">
               <a:lnSpc>
-                <a:spcPts val="1959"/>
+                <a:spcPts val="2500"/>
               </a:lnSpc>
-              <a:spcAft>
-                <a:spcPts val="400"/>
-              </a:spcAft>
             </a:pPr>
             <a:r>
-              <a:rPr sz="1400" b="0" i="1">
-                <a:solidFill>
-                  <a:srgbClr val="666666"/>
+              <a:rPr sz="1800" b="1" i="0">
+                <a:solidFill>
+                  <a:srgbClr val="4A90D9"/>
                 </a:solidFill>
                 <a:latin typeface="Calibri"/>
               </a:rPr>
-              <a:t>Whose voices trained the model? Likely YouTube Music’s library  - commercially successful, English-language, Western artists. The same structural bias as W4’s facial recognition datasets.</a:t>
-            </a:r>
-          </a:p>
-        </p:txBody>
-      </p:sp>
-    </p:spTree>
-  </p:cSld>
-  <p:clrMapOvr>
-    <a:masterClrMapping/>
-  </p:clrMapOvr>
-</p:sld>
-</file>
-
-<file path=ppt/slides/slide8.xml><?xml version="1.0" encoding="utf-8"?>
-<p:sld xmlns:a="http://schemas.openxmlformats.org/drawingml/2006/main" xmlns:p="http://schemas.openxmlformats.org/presentationml/2006/main" xmlns:r="http://schemas.openxmlformats.org/officeDocument/2006/relationships">
-  <p:cSld>
-    <p:bg>
-      <p:bgPr>
-        <a:solidFill>
-          <a:srgbClr val="1F3964"/>
-        </a:solidFill>
-        <a:effectLst/>
-      </p:bgPr>
-    </p:bg>
-    <p:spTree>
-      <p:nvGrpSpPr>
-        <p:cNvPr id="1" name=""/>
-        <p:cNvGrpSpPr/>
-        <p:nvPr/>
-      </p:nvGrpSpPr>
-      <p:grpSpPr/>
-      <p:sp>
-        <p:nvSpPr>
-          <p:cNvPr id="2" name="TextBox 1"/>
+              <a:t>3.</a:t>
+            </a:r>
+          </a:p>
+        </p:txBody>
+      </p:sp>
+      <p:sp>
+        <p:nvSpPr>
+          <p:cNvPr id="10" name="TextBox 9"/>
           <p:cNvSpPr txBox="1"/>
           <p:nvPr/>
         </p:nvSpPr>
         <p:spPr>
           <a:xfrm>
-            <a:off x="457200" y="365760"/>
-            <a:ext cx="914400" cy="457200"/>
+            <a:off x="1645920" y="4114800"/>
+            <a:ext cx="9144000" cy="731520"/>
           </a:xfrm>
           <a:prstGeom prst="rect">
             <a:avLst/>
@@ -5509,34 +5356,32 @@
           <a:p>
             <a:pPr algn="l">
               <a:lnSpc>
-                <a:spcPts val="1560"/>
+                <a:spcPts val="2200"/>
               </a:lnSpc>
-              <a:spcAft>
-                <a:spcPts val="400"/>
-              </a:spcAft>
             </a:pPr>
             <a:r>
-              <a:rPr sz="1200" b="1" i="0">
-                <a:solidFill>
-                  <a:srgbClr val="4A90D9"/>
+              <a:rPr sz="1600" b="0" i="0">
+                <a:solidFill>
+                  <a:srgbClr val="F2F2F2"/>
                 </a:solidFill>
                 <a:latin typeface="Calibri"/>
               </a:rPr>
-              <a:t>07</a:t>
-            </a:r>
-          </a:p>
-        </p:txBody>
-      </p:sp>
-      <p:sp>
-        <p:nvSpPr>
-          <p:cNvPr id="3" name="TextBox 2"/>
+              <a:t>Is there a difference between copying a melody
+and copying an emotional style? Where do you draw the line?</a:t>
+            </a:r>
+          </a:p>
+        </p:txBody>
+      </p:sp>
+      <p:sp>
+        <p:nvSpPr>
+          <p:cNvPr id="11" name="TextBox 10"/>
           <p:cNvSpPr txBox="1"/>
           <p:nvPr/>
         </p:nvSpPr>
         <p:spPr>
           <a:xfrm>
-            <a:off x="731520" y="731520"/>
-            <a:ext cx="10698480" cy="731520"/>
+            <a:off x="1097280" y="5029200"/>
+            <a:ext cx="457200" cy="457200"/>
           </a:xfrm>
           <a:prstGeom prst="rect">
             <a:avLst/>
@@ -5551,77 +5396,31 @@
           <a:p>
             <a:pPr algn="l">
               <a:lnSpc>
-                <a:spcPts val="4680"/>
+                <a:spcPts val="2500"/>
               </a:lnSpc>
-              <a:spcAft>
-                <a:spcPts val="400"/>
-              </a:spcAft>
             </a:pPr>
             <a:r>
-              <a:rPr sz="3600" b="1" i="0">
-                <a:solidFill>
-                  <a:srgbClr val="FFFFFF"/>
+              <a:rPr sz="1800" b="1" i="0">
+                <a:solidFill>
+                  <a:srgbClr val="4A90D9"/>
                 </a:solidFill>
                 <a:latin typeface="Calibri"/>
               </a:rPr>
-              <a:t>What Did We Learn?</a:t>
-            </a:r>
-          </a:p>
-        </p:txBody>
-      </p:sp>
-      <p:sp>
-        <p:nvSpPr>
-          <p:cNvPr id="4" name="Rectangle 3"/>
-          <p:cNvSpPr/>
-          <p:nvPr/>
-        </p:nvSpPr>
-        <p:spPr>
-          <a:xfrm>
-            <a:off x="731520" y="1554480"/>
-            <a:ext cx="2743200" cy="25400"/>
-          </a:xfrm>
-          <a:prstGeom prst="rect">
-            <a:avLst/>
-          </a:prstGeom>
-          <a:solidFill>
-            <a:srgbClr val="4A90D9"/>
-          </a:solidFill>
-          <a:ln>
-            <a:noFill/>
-          </a:ln>
-        </p:spPr>
-        <p:style>
-          <a:lnRef idx="1">
-            <a:schemeClr val="accent1"/>
-          </a:lnRef>
-          <a:fillRef idx="3">
-            <a:schemeClr val="accent1"/>
-          </a:fillRef>
-          <a:effectRef idx="2">
-            <a:schemeClr val="accent1"/>
-          </a:effectRef>
-          <a:fontRef idx="minor">
-            <a:schemeClr val="lt1"/>
-          </a:fontRef>
-        </p:style>
-        <p:txBody>
-          <a:bodyPr rtlCol="0" anchor="ctr"/>
-          <a:lstStyle/>
-          <a:p>
-            <a:pPr algn="ctr"/>
-          </a:p>
-        </p:txBody>
-      </p:sp>
-      <p:sp>
-        <p:nvSpPr>
-          <p:cNvPr id="5" name="TextBox 4"/>
+              <a:t>4.</a:t>
+            </a:r>
+          </a:p>
+        </p:txBody>
+      </p:sp>
+      <p:sp>
+        <p:nvSpPr>
+          <p:cNvPr id="12" name="TextBox 11"/>
           <p:cNvSpPr txBox="1"/>
           <p:nvPr/>
         </p:nvSpPr>
         <p:spPr>
           <a:xfrm>
-            <a:off x="1097280" y="2011680"/>
-            <a:ext cx="9966960" cy="2286000"/>
+            <a:off x="1645920" y="5029200"/>
+            <a:ext cx="9144000" cy="731520"/>
           </a:xfrm>
           <a:prstGeom prst="rect">
             <a:avLst/>
@@ -5636,34 +5435,32 @@
           <a:p>
             <a:pPr algn="l">
               <a:lnSpc>
-                <a:spcPts val="3000"/>
+                <a:spcPts val="2200"/>
               </a:lnSpc>
-              <a:spcAft>
-                <a:spcPts val="400"/>
-              </a:spcAft>
             </a:pPr>
             <a:r>
-              <a:rPr sz="2000" b="0" i="0">
-                <a:solidFill>
-                  <a:srgbClr val="FFFFFF"/>
+              <a:rPr sz="1600" b="0" i="0">
+                <a:solidFill>
+                  <a:srgbClr val="F2F2F2"/>
                 </a:solidFill>
                 <a:latin typeface="Calibri"/>
               </a:rPr>
-              <a:t>AI can replicate the emotional surface of music with startling fidelity. But this achievement is built on hidden human labour, devoid of embodied experience, and stripped of the creative struggle that gives music its deeper meaning.</a:t>
-            </a:r>
-          </a:p>
-        </p:txBody>
-      </p:sp>
-      <p:sp>
-        <p:nvSpPr>
-          <p:cNvPr id="6" name="TextBox 5"/>
+              <a:t>Would you pay the same for an AI-generated song
+as for a human-composed one? Why or why not?</a:t>
+            </a:r>
+          </a:p>
+        </p:txBody>
+      </p:sp>
+      <p:sp>
+        <p:nvSpPr>
+          <p:cNvPr id="13" name="TextBox 12"/>
           <p:cNvSpPr txBox="1"/>
           <p:nvPr/>
         </p:nvSpPr>
         <p:spPr>
           <a:xfrm>
-            <a:off x="1097280" y="4114800"/>
-            <a:ext cx="9966960" cy="914400"/>
+            <a:off x="1097280" y="5943600"/>
+            <a:ext cx="457200" cy="457200"/>
           </a:xfrm>
           <a:prstGeom prst="rect">
             <a:avLst/>
@@ -5678,34 +5475,31 @@
           <a:p>
             <a:pPr algn="l">
               <a:lnSpc>
-                <a:spcPts val="3079"/>
+                <a:spcPts val="2500"/>
               </a:lnSpc>
-              <a:spcAft>
-                <a:spcPts val="400"/>
-              </a:spcAft>
             </a:pPr>
             <a:r>
-              <a:rPr sz="2200" b="1" i="0">
+              <a:rPr sz="1800" b="1" i="0">
                 <a:solidFill>
                   <a:srgbClr val="4A90D9"/>
                 </a:solidFill>
                 <a:latin typeface="Calibri"/>
               </a:rPr>
-              <a:t>The question is no longer whether AI can make good music.</a:t>
-            </a:r>
-          </a:p>
-        </p:txBody>
-      </p:sp>
-      <p:sp>
-        <p:nvSpPr>
-          <p:cNvPr id="7" name="TextBox 6"/>
+              <a:t>5.</a:t>
+            </a:r>
+          </a:p>
+        </p:txBody>
+      </p:sp>
+      <p:sp>
+        <p:nvSpPr>
+          <p:cNvPr id="14" name="TextBox 13"/>
           <p:cNvSpPr txBox="1"/>
           <p:nvPr/>
         </p:nvSpPr>
         <p:spPr>
           <a:xfrm>
-            <a:off x="1097280" y="4846320"/>
-            <a:ext cx="9966960" cy="914400"/>
+            <a:off x="1645920" y="5943600"/>
+            <a:ext cx="9144000" cy="731520"/>
           </a:xfrm>
           <a:prstGeom prst="rect">
             <a:avLst/>
@@ -5720,34 +5514,32 @@
           <a:p>
             <a:pPr algn="l">
               <a:lnSpc>
-                <a:spcPts val="3919"/>
+                <a:spcPts val="2200"/>
               </a:lnSpc>
-              <a:spcAft>
-                <a:spcPts val="400"/>
-              </a:spcAft>
             </a:pPr>
             <a:r>
-              <a:rPr sz="2800" b="1" i="1">
-                <a:solidFill>
-                  <a:srgbClr val="FFFFFF"/>
+              <a:rPr sz="1600" b="0" i="0">
+                <a:solidFill>
+                  <a:srgbClr val="F2F2F2"/>
                 </a:solidFill>
                 <a:latin typeface="Calibri"/>
               </a:rPr>
-              <a:t>It already can.</a:t>
-            </a:r>
-          </a:p>
-        </p:txBody>
-      </p:sp>
-      <p:sp>
-        <p:nvSpPr>
-          <p:cNvPr id="8" name="TextBox 7"/>
+              <a:t>Did the AI collaborate with me,
+or did I just press a button?</a:t>
+            </a:r>
+          </a:p>
+        </p:txBody>
+      </p:sp>
+      <p:sp>
+        <p:nvSpPr>
+          <p:cNvPr id="15" name="TextBox 14"/>
           <p:cNvSpPr txBox="1"/>
           <p:nvPr/>
         </p:nvSpPr>
         <p:spPr>
           <a:xfrm>
-            <a:off x="1097280" y="5486400"/>
-            <a:ext cx="9966960" cy="914400"/>
+            <a:off x="731520" y="6400800"/>
+            <a:ext cx="10698480" cy="365760"/>
           </a:xfrm>
           <a:prstGeom prst="rect">
             <a:avLst/>
@@ -5760,254 +5552,13 @@
           </a:bodyPr>
           <a:lstStyle/>
           <a:p>
-            <a:pPr algn="l">
-              <a:lnSpc>
-                <a:spcPts val="2550"/>
-              </a:lnSpc>
-              <a:spcAft>
-                <a:spcPts val="400"/>
-              </a:spcAft>
-            </a:pPr>
-            <a:r>
-              <a:rPr sz="1700" b="0" i="1">
-                <a:solidFill>
-                  <a:srgbClr val="F2F2F2"/>
-                </a:solidFill>
-                <a:latin typeface="Calibri"/>
-              </a:rPr>
-              <a:t>The question is whether we, as listeners and as a society, will demand authenticity of process  - or whether the result alone will be enough.</a:t>
-            </a:r>
-          </a:p>
-        </p:txBody>
-      </p:sp>
-    </p:spTree>
-  </p:cSld>
-  <p:clrMapOvr>
-    <a:masterClrMapping/>
-  </p:clrMapOvr>
-</p:sld>
-</file>
-
-<file path=ppt/slides/slide9.xml><?xml version="1.0" encoding="utf-8"?>
-<p:sld xmlns:a="http://schemas.openxmlformats.org/drawingml/2006/main" xmlns:p="http://schemas.openxmlformats.org/presentationml/2006/main" xmlns:r="http://schemas.openxmlformats.org/officeDocument/2006/relationships">
-  <p:cSld>
-    <p:bg>
-      <p:bgPr>
-        <a:solidFill>
-          <a:srgbClr val="1F3964"/>
-        </a:solidFill>
-        <a:effectLst/>
-      </p:bgPr>
-    </p:bg>
-    <p:spTree>
-      <p:nvGrpSpPr>
-        <p:cNvPr id="1" name=""/>
-        <p:cNvGrpSpPr/>
-        <p:nvPr/>
-      </p:nvGrpSpPr>
-      <p:grpSpPr/>
-      <p:sp>
-        <p:nvSpPr>
-          <p:cNvPr id="2" name="TextBox 1"/>
-          <p:cNvSpPr txBox="1"/>
-          <p:nvPr/>
-        </p:nvSpPr>
-        <p:spPr>
-          <a:xfrm>
-            <a:off x="731520" y="1371600"/>
-            <a:ext cx="10698480" cy="914400"/>
-          </a:xfrm>
-          <a:prstGeom prst="rect">
-            <a:avLst/>
-          </a:prstGeom>
-          <a:noFill/>
-        </p:spPr>
-        <p:txBody>
-          <a:bodyPr wrap="square">
-            <a:spAutoFit/>
-          </a:bodyPr>
-          <a:lstStyle/>
-          <a:p>
             <a:pPr algn="ctr">
               <a:lnSpc>
-                <a:spcPts val="5200"/>
+                <a:spcPts val="1600"/>
               </a:lnSpc>
-              <a:spcAft>
-                <a:spcPts val="400"/>
-              </a:spcAft>
             </a:pPr>
             <a:r>
-              <a:rPr sz="4000" b="1" i="0">
-                <a:solidFill>
-                  <a:srgbClr val="FFFFFF"/>
-                </a:solidFill>
-                <a:latin typeface="Calibri"/>
-              </a:rPr>
-              <a:t>Discussion</a:t>
-            </a:r>
-          </a:p>
-        </p:txBody>
-      </p:sp>
-      <p:sp>
-        <p:nvSpPr>
-          <p:cNvPr id="3" name="Rectangle 2"/>
-          <p:cNvSpPr/>
-          <p:nvPr/>
-        </p:nvSpPr>
-        <p:spPr>
-          <a:xfrm>
-            <a:off x="4114800" y="2468880"/>
-            <a:ext cx="3931920" cy="25400"/>
-          </a:xfrm>
-          <a:prstGeom prst="rect">
-            <a:avLst/>
-          </a:prstGeom>
-          <a:solidFill>
-            <a:srgbClr val="4A90D9"/>
-          </a:solidFill>
-          <a:ln>
-            <a:noFill/>
-          </a:ln>
-        </p:spPr>
-        <p:style>
-          <a:lnRef idx="1">
-            <a:schemeClr val="accent1"/>
-          </a:lnRef>
-          <a:fillRef idx="3">
-            <a:schemeClr val="accent1"/>
-          </a:fillRef>
-          <a:effectRef idx="2">
-            <a:schemeClr val="accent1"/>
-          </a:effectRef>
-          <a:fontRef idx="minor">
-            <a:schemeClr val="lt1"/>
-          </a:fontRef>
-        </p:style>
-        <p:txBody>
-          <a:bodyPr rtlCol="0" anchor="ctr"/>
-          <a:lstStyle/>
-          <a:p>
-            <a:pPr algn="ctr"/>
-          </a:p>
-        </p:txBody>
-      </p:sp>
-      <p:sp>
-        <p:nvSpPr>
-          <p:cNvPr id="4" name="TextBox 3"/>
-          <p:cNvSpPr txBox="1"/>
-          <p:nvPr/>
-        </p:nvSpPr>
-        <p:spPr>
-          <a:xfrm>
-            <a:off x="1828800" y="2926080"/>
-            <a:ext cx="8503920" cy="914400"/>
-          </a:xfrm>
-          <a:prstGeom prst="rect">
-            <a:avLst/>
-          </a:prstGeom>
-          <a:noFill/>
-        </p:spPr>
-        <p:txBody>
-          <a:bodyPr wrap="square">
-            <a:spAutoFit/>
-          </a:bodyPr>
-          <a:lstStyle/>
-          <a:p>
-            <a:pPr algn="ctr">
-              <a:lnSpc>
-                <a:spcPts val="3300"/>
-              </a:lnSpc>
-              <a:spcAft>
-                <a:spcPts val="400"/>
-              </a:spcAft>
-            </a:pPr>
-            <a:r>
-              <a:rPr sz="2200" b="0" i="1">
-                <a:solidFill>
-                  <a:srgbClr val="4A90D9"/>
-                </a:solidFill>
-                <a:latin typeface="Calibri"/>
-              </a:rPr>
-              <a:t>If you couldn’t tell whether a song was made by a human or AI,
-would the answer change how it makes you feel?</a:t>
-            </a:r>
-          </a:p>
-        </p:txBody>
-      </p:sp>
-      <p:sp>
-        <p:nvSpPr>
-          <p:cNvPr id="5" name="TextBox 4"/>
-          <p:cNvSpPr txBox="1"/>
-          <p:nvPr/>
-        </p:nvSpPr>
-        <p:spPr>
-          <a:xfrm>
-            <a:off x="1828800" y="4572000"/>
-            <a:ext cx="8503920" cy="914400"/>
-          </a:xfrm>
-          <a:prstGeom prst="rect">
-            <a:avLst/>
-          </a:prstGeom>
-          <a:noFill/>
-        </p:spPr>
-        <p:txBody>
-          <a:bodyPr wrap="square">
-            <a:spAutoFit/>
-          </a:bodyPr>
-          <a:lstStyle/>
-          <a:p>
-            <a:pPr algn="ctr">
-              <a:lnSpc>
-                <a:spcPts val="2340"/>
-              </a:lnSpc>
-              <a:spcAft>
-                <a:spcPts val="400"/>
-              </a:spcAft>
-            </a:pPr>
-            <a:r>
-              <a:rPr sz="1800" b="0" i="0">
-                <a:solidFill>
-                  <a:srgbClr val="F2F2F2"/>
-                </a:solidFill>
-                <a:latin typeface="Calibri"/>
-              </a:rPr>
-              <a:t>Let’s listen to the tracks and discuss.</a:t>
-            </a:r>
-          </a:p>
-        </p:txBody>
-      </p:sp>
-      <p:sp>
-        <p:nvSpPr>
-          <p:cNvPr id="6" name="TextBox 5"/>
-          <p:cNvSpPr txBox="1"/>
-          <p:nvPr/>
-        </p:nvSpPr>
-        <p:spPr>
-          <a:xfrm>
-            <a:off x="1828800" y="5669280"/>
-            <a:ext cx="8503920" cy="457200"/>
-          </a:xfrm>
-          <a:prstGeom prst="rect">
-            <a:avLst/>
-          </a:prstGeom>
-          <a:noFill/>
-        </p:spPr>
-        <p:txBody>
-          <a:bodyPr wrap="square">
-            <a:spAutoFit/>
-          </a:bodyPr>
-          <a:lstStyle/>
-          <a:p>
-            <a:pPr algn="ctr">
-              <a:lnSpc>
-                <a:spcPts val="1690"/>
-              </a:lnSpc>
-              <a:spcAft>
-                <a:spcPts val="400"/>
-              </a:spcAft>
-            </a:pPr>
-            <a:r>
-              <a:rPr sz="1300" b="0" i="0">
+              <a:rPr sz="1200" b="0" i="0">
                 <a:solidFill>
                   <a:srgbClr val="666666"/>
                 </a:solidFill>

</xml_diff>

<commit_message>
Switch presentation to forest green color theme
Deep green background with leaf green accents and amber warnings.
Fits the "Synthetic Pine" concept.

Co-Authored-By: Claude Opus 4.6 (1M context) <noreply@anthropic.com>
</commit_message>
<xml_diff>
--- a/Assignment_1_AI_Music_Generation/PHKI_Assignment1_Presentation.pptx
+++ b/Assignment_1_AI_Music_Generation/PHKI_Assignment1_Presentation.pptx
@@ -3090,7 +3090,7 @@
     <p:bg>
       <p:bgPr>
         <a:solidFill>
-          <a:srgbClr val="1F3964"/>
+          <a:srgbClr val="1A2A1A"/>
         </a:solidFill>
         <a:effectLst/>
       </p:bgPr>
@@ -3132,7 +3132,7 @@
             <a:r>
               <a:rPr sz="4400" b="1" i="0">
                 <a:solidFill>
-                  <a:srgbClr val="FFFFFF"/>
+                  <a:srgbClr val="F5F5F0"/>
                 </a:solidFill>
                 <a:latin typeface="Calibri"/>
               </a:rPr>
@@ -3156,7 +3156,7 @@
             <a:avLst/>
           </a:prstGeom>
           <a:solidFill>
-            <a:srgbClr val="4A90D9"/>
+            <a:srgbClr val="6BB56A"/>
           </a:solidFill>
           <a:ln>
             <a:noFill/>
@@ -3214,7 +3214,7 @@
             <a:r>
               <a:rPr sz="2400" b="0" i="1">
                 <a:solidFill>
-                  <a:srgbClr val="4A90D9"/>
+                  <a:srgbClr val="6BB56A"/>
                 </a:solidFill>
                 <a:latin typeface="Calibri"/>
               </a:rPr>
@@ -3253,7 +3253,7 @@
             <a:r>
               <a:rPr sz="1400" b="0" i="0">
                 <a:solidFill>
-                  <a:srgbClr val="666666"/>
+                  <a:srgbClr val="7A8A72"/>
                 </a:solidFill>
                 <a:latin typeface="Calibri"/>
               </a:rPr>
@@ -3276,7 +3276,7 @@
     <p:bg>
       <p:bgPr>
         <a:solidFill>
-          <a:srgbClr val="1F3964"/>
+          <a:srgbClr val="1A2A1A"/>
         </a:solidFill>
         <a:effectLst/>
       </p:bgPr>
@@ -3318,7 +3318,7 @@
             <a:r>
               <a:rPr sz="3600" b="1" i="0">
                 <a:solidFill>
-                  <a:srgbClr val="FFFFFF"/>
+                  <a:srgbClr val="F5F5F0"/>
                 </a:solidFill>
                 <a:latin typeface="Calibri"/>
               </a:rPr>
@@ -3342,7 +3342,7 @@
             <a:avLst/>
           </a:prstGeom>
           <a:solidFill>
-            <a:srgbClr val="4A90D9"/>
+            <a:srgbClr val="6BB56A"/>
           </a:solidFill>
           <a:ln>
             <a:noFill/>
@@ -3400,7 +3400,7 @@
             <a:r>
               <a:rPr sz="2000" b="0" i="0">
                 <a:solidFill>
-                  <a:srgbClr val="F2F2F2"/>
+                  <a:srgbClr val="D4D9CE"/>
                 </a:solidFill>
                 <a:latin typeface="Calibri"/>
               </a:rPr>
@@ -3439,7 +3439,7 @@
             <a:r>
               <a:rPr sz="1800" b="1" i="0">
                 <a:solidFill>
-                  <a:srgbClr val="4A90D9"/>
+                  <a:srgbClr val="6BB56A"/>
                 </a:solidFill>
                 <a:latin typeface="Calibri"/>
               </a:rPr>
@@ -3481,7 +3481,7 @@
             <a:r>
               <a:rPr sz="1800">
                 <a:solidFill>
-                  <a:srgbClr val="F2F2F2"/>
+                  <a:srgbClr val="D4D9CE"/>
                 </a:solidFill>
                 <a:latin typeface="Calibri"/>
               </a:rPr>
@@ -3500,7 +3500,7 @@
             <a:r>
               <a:rPr sz="1800">
                 <a:solidFill>
-                  <a:srgbClr val="F2F2F2"/>
+                  <a:srgbClr val="D4D9CE"/>
                 </a:solidFill>
                 <a:latin typeface="Calibri"/>
               </a:rPr>
@@ -3539,7 +3539,7 @@
             <a:r>
               <a:rPr sz="1600" b="0" i="1">
                 <a:solidFill>
-                  <a:srgbClr val="666666"/>
+                  <a:srgbClr val="7A8A72"/>
                 </a:solidFill>
                 <a:latin typeface="Calibri"/>
               </a:rPr>
@@ -3562,7 +3562,7 @@
     <p:bg>
       <p:bgPr>
         <a:solidFill>
-          <a:srgbClr val="1F3964"/>
+          <a:srgbClr val="1A2A1A"/>
         </a:solidFill>
         <a:effectLst/>
       </p:bgPr>
@@ -3604,7 +3604,7 @@
             <a:r>
               <a:rPr sz="3000" b="1" i="0">
                 <a:solidFill>
-                  <a:srgbClr val="FFFFFF"/>
+                  <a:srgbClr val="F5F5F0"/>
                 </a:solidFill>
                 <a:latin typeface="Calibri"/>
               </a:rPr>
@@ -3628,7 +3628,7 @@
             <a:avLst/>
           </a:prstGeom>
           <a:solidFill>
-            <a:srgbClr val="4A90D9"/>
+            <a:srgbClr val="6BB56A"/>
           </a:solidFill>
           <a:ln>
             <a:noFill/>
@@ -3686,7 +3686,7 @@
             <a:r>
               <a:rPr sz="1200" b="1" i="0">
                 <a:solidFill>
-                  <a:srgbClr val="4A90D9"/>
+                  <a:srgbClr val="6BB56A"/>
                 </a:solidFill>
                 <a:latin typeface="Calibri"/>
               </a:rPr>
@@ -3725,7 +3725,7 @@
             <a:r>
               <a:rPr sz="1500" b="0" i="1">
                 <a:solidFill>
-                  <a:srgbClr val="F2F2F2"/>
+                  <a:srgbClr val="D4D9CE"/>
                 </a:solidFill>
                 <a:latin typeface="Calibri"/>
               </a:rPr>
@@ -3764,7 +3764,7 @@
             <a:r>
               <a:rPr sz="1200" b="1" i="0">
                 <a:solidFill>
-                  <a:srgbClr val="D48B2C"/>
+                  <a:srgbClr val="E8A83E"/>
                 </a:solidFill>
                 <a:latin typeface="Calibri"/>
               </a:rPr>
@@ -3803,7 +3803,7 @@
             <a:r>
               <a:rPr sz="1400" b="0" i="0">
                 <a:solidFill>
-                  <a:srgbClr val="F2F2F2"/>
+                  <a:srgbClr val="D4D9CE"/>
                 </a:solidFill>
                 <a:latin typeface="Calibri"/>
               </a:rPr>
@@ -3842,7 +3842,7 @@
             <a:r>
               <a:rPr sz="2200" b="1" i="0">
                 <a:solidFill>
-                  <a:srgbClr val="FFFFFF"/>
+                  <a:srgbClr val="F5F5F0"/>
                 </a:solidFill>
                 <a:latin typeface="Calibri"/>
               </a:rPr>
@@ -3881,7 +3881,7 @@
             <a:r>
               <a:rPr sz="1400" b="0" i="0">
                 <a:solidFill>
-                  <a:srgbClr val="666666"/>
+                  <a:srgbClr val="7A8A72"/>
                 </a:solidFill>
                 <a:latin typeface="Calibri"/>
               </a:rPr>
@@ -3928,7 +3928,7 @@
     <p:bg>
       <p:bgPr>
         <a:solidFill>
-          <a:srgbClr val="1F3964"/>
+          <a:srgbClr val="1A2A1A"/>
         </a:solidFill>
         <a:effectLst/>
       </p:bgPr>
@@ -3970,7 +3970,7 @@
             <a:r>
               <a:rPr sz="3000" b="1" i="0">
                 <a:solidFill>
-                  <a:srgbClr val="FFFFFF"/>
+                  <a:srgbClr val="F5F5F0"/>
                 </a:solidFill>
                 <a:latin typeface="Calibri"/>
               </a:rPr>
@@ -3994,7 +3994,7 @@
             <a:avLst/>
           </a:prstGeom>
           <a:solidFill>
-            <a:srgbClr val="4A90D9"/>
+            <a:srgbClr val="6BB56A"/>
           </a:solidFill>
           <a:ln>
             <a:noFill/>
@@ -4052,7 +4052,7 @@
             <a:r>
               <a:rPr sz="1200" b="1" i="0">
                 <a:solidFill>
-                  <a:srgbClr val="4A90D9"/>
+                  <a:srgbClr val="6BB56A"/>
                 </a:solidFill>
                 <a:latin typeface="Calibri"/>
               </a:rPr>
@@ -4091,7 +4091,7 @@
             <a:r>
               <a:rPr sz="1500" b="0" i="1">
                 <a:solidFill>
-                  <a:srgbClr val="F2F2F2"/>
+                  <a:srgbClr val="D4D9CE"/>
                 </a:solidFill>
                 <a:latin typeface="Calibri"/>
               </a:rPr>
@@ -4130,7 +4130,7 @@
             <a:r>
               <a:rPr sz="1200" b="1" i="0">
                 <a:solidFill>
-                  <a:srgbClr val="D48B2C"/>
+                  <a:srgbClr val="E8A83E"/>
                 </a:solidFill>
                 <a:latin typeface="Calibri"/>
               </a:rPr>
@@ -4169,7 +4169,7 @@
             <a:r>
               <a:rPr sz="1400" b="0" i="0">
                 <a:solidFill>
-                  <a:srgbClr val="F2F2F2"/>
+                  <a:srgbClr val="D4D9CE"/>
                 </a:solidFill>
                 <a:latin typeface="Calibri"/>
               </a:rPr>
@@ -4208,7 +4208,7 @@
             <a:r>
               <a:rPr sz="2200" b="1" i="0">
                 <a:solidFill>
-                  <a:srgbClr val="FFFFFF"/>
+                  <a:srgbClr val="F5F5F0"/>
                 </a:solidFill>
                 <a:latin typeface="Calibri"/>
               </a:rPr>
@@ -4247,7 +4247,7 @@
             <a:r>
               <a:rPr sz="1400" b="0" i="0">
                 <a:solidFill>
-                  <a:srgbClr val="666666"/>
+                  <a:srgbClr val="7A8A72"/>
                 </a:solidFill>
                 <a:latin typeface="Calibri"/>
               </a:rPr>
@@ -4294,7 +4294,7 @@
     <p:bg>
       <p:bgPr>
         <a:solidFill>
-          <a:srgbClr val="1F3964"/>
+          <a:srgbClr val="1A2A1A"/>
         </a:solidFill>
         <a:effectLst/>
       </p:bgPr>
@@ -4336,7 +4336,7 @@
             <a:r>
               <a:rPr sz="3600" b="1" i="0">
                 <a:solidFill>
-                  <a:srgbClr val="FFFFFF"/>
+                  <a:srgbClr val="F5F5F0"/>
                 </a:solidFill>
                 <a:latin typeface="Calibri"/>
               </a:rPr>
@@ -4360,7 +4360,7 @@
             <a:avLst/>
           </a:prstGeom>
           <a:solidFill>
-            <a:srgbClr val="4A90D9"/>
+            <a:srgbClr val="6BB56A"/>
           </a:solidFill>
           <a:ln>
             <a:noFill/>
@@ -4421,7 +4421,7 @@
             <a:r>
               <a:rPr sz="1700">
                 <a:solidFill>
-                  <a:srgbClr val="F2F2F2"/>
+                  <a:srgbClr val="D4D9CE"/>
                 </a:solidFill>
                 <a:latin typeface="Calibri"/>
               </a:rPr>
@@ -4440,7 +4440,7 @@
             <a:r>
               <a:rPr sz="1700">
                 <a:solidFill>
-                  <a:srgbClr val="F2F2F2"/>
+                  <a:srgbClr val="D4D9CE"/>
                 </a:solidFill>
                 <a:latin typeface="Calibri"/>
               </a:rPr>
@@ -4459,7 +4459,7 @@
             <a:r>
               <a:rPr sz="1700">
                 <a:solidFill>
-                  <a:srgbClr val="F2F2F2"/>
+                  <a:srgbClr val="D4D9CE"/>
                 </a:solidFill>
                 <a:latin typeface="Calibri"/>
               </a:rPr>
@@ -4478,7 +4478,7 @@
             <a:r>
               <a:rPr sz="1700">
                 <a:solidFill>
-                  <a:srgbClr val="F2F2F2"/>
+                  <a:srgbClr val="D4D9CE"/>
                 </a:solidFill>
                 <a:latin typeface="Calibri"/>
               </a:rPr>
@@ -4497,7 +4497,7 @@
             <a:r>
               <a:rPr sz="1700">
                 <a:solidFill>
-                  <a:srgbClr val="F2F2F2"/>
+                  <a:srgbClr val="D4D9CE"/>
                 </a:solidFill>
                 <a:latin typeface="Calibri"/>
               </a:rPr>
@@ -4516,7 +4516,7 @@
             <a:r>
               <a:rPr sz="1700">
                 <a:solidFill>
-                  <a:srgbClr val="F2F2F2"/>
+                  <a:srgbClr val="D4D9CE"/>
                 </a:solidFill>
                 <a:latin typeface="Calibri"/>
               </a:rPr>
@@ -4539,7 +4539,7 @@
     <p:bg>
       <p:bgPr>
         <a:solidFill>
-          <a:srgbClr val="1F3964"/>
+          <a:srgbClr val="1A2A1A"/>
         </a:solidFill>
         <a:effectLst/>
       </p:bgPr>
@@ -4581,7 +4581,7 @@
             <a:r>
               <a:rPr sz="3600" b="1" i="0">
                 <a:solidFill>
-                  <a:srgbClr val="FFFFFF"/>
+                  <a:srgbClr val="F5F5F0"/>
                 </a:solidFill>
                 <a:latin typeface="Calibri"/>
               </a:rPr>
@@ -4605,7 +4605,7 @@
             <a:avLst/>
           </a:prstGeom>
           <a:solidFill>
-            <a:srgbClr val="4A90D9"/>
+            <a:srgbClr val="6BB56A"/>
           </a:solidFill>
           <a:ln>
             <a:noFill/>
@@ -4663,7 +4663,7 @@
             <a:r>
               <a:rPr sz="1200" b="1" i="0">
                 <a:solidFill>
-                  <a:srgbClr val="4A90D9"/>
+                  <a:srgbClr val="6BB56A"/>
                 </a:solidFill>
                 <a:latin typeface="Calibri"/>
               </a:rPr>
@@ -4702,7 +4702,7 @@
             <a:r>
               <a:rPr sz="1500" b="0" i="0">
                 <a:solidFill>
-                  <a:srgbClr val="F2F2F2"/>
+                  <a:srgbClr val="D4D9CE"/>
                 </a:solidFill>
                 <a:latin typeface="Calibri"/>
               </a:rPr>
@@ -4742,7 +4742,7 @@
             <a:r>
               <a:rPr sz="1200" b="1" i="0">
                 <a:solidFill>
-                  <a:srgbClr val="4A90D9"/>
+                  <a:srgbClr val="6BB56A"/>
                 </a:solidFill>
                 <a:latin typeface="Calibri"/>
               </a:rPr>
@@ -4781,7 +4781,7 @@
             <a:r>
               <a:rPr sz="1500" b="0" i="0">
                 <a:solidFill>
-                  <a:srgbClr val="F2F2F2"/>
+                  <a:srgbClr val="D4D9CE"/>
                 </a:solidFill>
                 <a:latin typeface="Calibri"/>
               </a:rPr>
@@ -4821,7 +4821,7 @@
             <a:r>
               <a:rPr sz="1200" b="1" i="0">
                 <a:solidFill>
-                  <a:srgbClr val="4A90D9"/>
+                  <a:srgbClr val="6BB56A"/>
                 </a:solidFill>
                 <a:latin typeface="Calibri"/>
               </a:rPr>
@@ -4860,7 +4860,7 @@
             <a:r>
               <a:rPr sz="1500" b="0" i="0">
                 <a:solidFill>
-                  <a:srgbClr val="F2F2F2"/>
+                  <a:srgbClr val="D4D9CE"/>
                 </a:solidFill>
                 <a:latin typeface="Calibri"/>
               </a:rPr>
@@ -4900,7 +4900,7 @@
             <a:r>
               <a:rPr sz="1200" b="1" i="0">
                 <a:solidFill>
-                  <a:srgbClr val="4A90D9"/>
+                  <a:srgbClr val="6BB56A"/>
                 </a:solidFill>
                 <a:latin typeface="Calibri"/>
               </a:rPr>
@@ -4939,7 +4939,7 @@
             <a:r>
               <a:rPr sz="1500" b="0" i="0">
                 <a:solidFill>
-                  <a:srgbClr val="F2F2F2"/>
+                  <a:srgbClr val="D4D9CE"/>
                 </a:solidFill>
                 <a:latin typeface="Calibri"/>
               </a:rPr>
@@ -4979,7 +4979,7 @@
             <a:r>
               <a:rPr sz="2000" b="0" i="1">
                 <a:solidFill>
-                  <a:srgbClr val="FFFFFF"/>
+                  <a:srgbClr val="F5F5F0"/>
                 </a:solidFill>
                 <a:latin typeface="Calibri"/>
               </a:rPr>
@@ -5002,7 +5002,7 @@
     <p:bg>
       <p:bgPr>
         <a:solidFill>
-          <a:srgbClr val="1F3964"/>
+          <a:srgbClr val="1A2A1A"/>
         </a:solidFill>
         <a:effectLst/>
       </p:bgPr>
@@ -5044,7 +5044,7 @@
             <a:r>
               <a:rPr sz="4000" b="1" i="0">
                 <a:solidFill>
-                  <a:srgbClr val="FFFFFF"/>
+                  <a:srgbClr val="F5F5F0"/>
                 </a:solidFill>
                 <a:latin typeface="Calibri"/>
               </a:rPr>
@@ -5068,7 +5068,7 @@
             <a:avLst/>
           </a:prstGeom>
           <a:solidFill>
-            <a:srgbClr val="4A90D9"/>
+            <a:srgbClr val="6BB56A"/>
           </a:solidFill>
           <a:ln>
             <a:noFill/>
@@ -5126,7 +5126,7 @@
             <a:r>
               <a:rPr sz="1500" b="0" i="1">
                 <a:solidFill>
-                  <a:srgbClr val="666666"/>
+                  <a:srgbClr val="7A8A72"/>
                 </a:solidFill>
                 <a:latin typeface="Calibri"/>
               </a:rPr>
@@ -5165,7 +5165,7 @@
             <a:r>
               <a:rPr sz="1800" b="1" i="0">
                 <a:solidFill>
-                  <a:srgbClr val="4A90D9"/>
+                  <a:srgbClr val="6BB56A"/>
                 </a:solidFill>
                 <a:latin typeface="Calibri"/>
               </a:rPr>
@@ -5204,7 +5204,7 @@
             <a:r>
               <a:rPr sz="1600" b="0" i="0">
                 <a:solidFill>
-                  <a:srgbClr val="F2F2F2"/>
+                  <a:srgbClr val="D4D9CE"/>
                 </a:solidFill>
                 <a:latin typeface="Calibri"/>
               </a:rPr>
@@ -5244,7 +5244,7 @@
             <a:r>
               <a:rPr sz="1800" b="1" i="0">
                 <a:solidFill>
-                  <a:srgbClr val="4A90D9"/>
+                  <a:srgbClr val="6BB56A"/>
                 </a:solidFill>
                 <a:latin typeface="Calibri"/>
               </a:rPr>
@@ -5283,7 +5283,7 @@
             <a:r>
               <a:rPr sz="1600" b="0" i="0">
                 <a:solidFill>
-                  <a:srgbClr val="F2F2F2"/>
+                  <a:srgbClr val="D4D9CE"/>
                 </a:solidFill>
                 <a:latin typeface="Calibri"/>
               </a:rPr>
@@ -5323,7 +5323,7 @@
             <a:r>
               <a:rPr sz="1800" b="1" i="0">
                 <a:solidFill>
-                  <a:srgbClr val="4A90D9"/>
+                  <a:srgbClr val="6BB56A"/>
                 </a:solidFill>
                 <a:latin typeface="Calibri"/>
               </a:rPr>
@@ -5362,7 +5362,7 @@
             <a:r>
               <a:rPr sz="1600" b="0" i="0">
                 <a:solidFill>
-                  <a:srgbClr val="F2F2F2"/>
+                  <a:srgbClr val="D4D9CE"/>
                 </a:solidFill>
                 <a:latin typeface="Calibri"/>
               </a:rPr>
@@ -5402,7 +5402,7 @@
             <a:r>
               <a:rPr sz="1800" b="1" i="0">
                 <a:solidFill>
-                  <a:srgbClr val="4A90D9"/>
+                  <a:srgbClr val="6BB56A"/>
                 </a:solidFill>
                 <a:latin typeface="Calibri"/>
               </a:rPr>
@@ -5441,7 +5441,7 @@
             <a:r>
               <a:rPr sz="1600" b="0" i="0">
                 <a:solidFill>
-                  <a:srgbClr val="F2F2F2"/>
+                  <a:srgbClr val="D4D9CE"/>
                 </a:solidFill>
                 <a:latin typeface="Calibri"/>
               </a:rPr>
@@ -5481,7 +5481,7 @@
             <a:r>
               <a:rPr sz="1800" b="1" i="0">
                 <a:solidFill>
-                  <a:srgbClr val="4A90D9"/>
+                  <a:srgbClr val="6BB56A"/>
                 </a:solidFill>
                 <a:latin typeface="Calibri"/>
               </a:rPr>
@@ -5520,7 +5520,7 @@
             <a:r>
               <a:rPr sz="1600" b="0" i="0">
                 <a:solidFill>
-                  <a:srgbClr val="F2F2F2"/>
+                  <a:srgbClr val="D4D9CE"/>
                 </a:solidFill>
                 <a:latin typeface="Calibri"/>
               </a:rPr>
@@ -5560,7 +5560,7 @@
             <a:r>
               <a:rPr sz="1200" b="0" i="0">
                 <a:solidFill>
-                  <a:srgbClr val="666666"/>
+                  <a:srgbClr val="7A8A72"/>
                 </a:solidFill>
                 <a:latin typeface="Calibri"/>
               </a:rPr>

</xml_diff>